<commit_message>
Work on admin guide
</commit_message>
<xml_diff>
--- a/assets/images/Administration_Experiments.pptx
+++ b/assets/images/Administration_Experiments.pptx
@@ -5,11 +5,18 @@
     <p:sldMasterId id="2147483684" r:id="rId4"/>
   </p:sldMasterIdLst>
   <p:notesMasterIdLst>
-    <p:notesMasterId r:id="rId7"/>
+    <p:notesMasterId r:id="rId14"/>
   </p:notesMasterIdLst>
   <p:sldIdLst>
     <p:sldId id="256" r:id="rId5"/>
     <p:sldId id="257" r:id="rId6"/>
+    <p:sldId id="258" r:id="rId7"/>
+    <p:sldId id="259" r:id="rId8"/>
+    <p:sldId id="260" r:id="rId9"/>
+    <p:sldId id="263" r:id="rId10"/>
+    <p:sldId id="261" r:id="rId11"/>
+    <p:sldId id="262" r:id="rId12"/>
+    <p:sldId id="264" r:id="rId13"/>
   </p:sldIdLst>
   <p:sldSz cx="21601113" cy="14400213"/>
   <p:notesSz cx="9144000" cy="6858000"/>
@@ -403,7 +410,7 @@
           <a:p>
             <a:fld id="{43466010-90F5-41E6-AAE8-7E580DBF8C7C}" type="datetimeFigureOut">
               <a:rPr lang="en-DK" smtClean="0"/>
-              <a:t>23/02/2026</a:t>
+              <a:t>26/02/2026</a:t>
             </a:fld>
             <a:endParaRPr lang="en-DK"/>
           </a:p>
@@ -759,94 +766,6 @@
 </p:notes>
 </file>
 
-<file path=ppt/notesSlides/notesSlide2.xml><?xml version="1.0" encoding="utf-8"?>
-<p:notes xmlns:a="http://schemas.openxmlformats.org/drawingml/2006/main" xmlns:r="http://schemas.openxmlformats.org/officeDocument/2006/relationships" xmlns:p="http://schemas.openxmlformats.org/presentationml/2006/main">
-  <p:cSld>
-    <p:spTree>
-      <p:nvGrpSpPr>
-        <p:cNvPr id="1" name=""/>
-        <p:cNvGrpSpPr/>
-        <p:nvPr/>
-      </p:nvGrpSpPr>
-      <p:grpSpPr>
-        <a:xfrm>
-          <a:off x="0" y="0"/>
-          <a:ext cx="0" cy="0"/>
-          <a:chOff x="0" y="0"/>
-          <a:chExt cx="0" cy="0"/>
-        </a:xfrm>
-      </p:grpSpPr>
-      <p:sp>
-        <p:nvSpPr>
-          <p:cNvPr id="2" name="Slide Image Placeholder 1"/>
-          <p:cNvSpPr>
-            <a:spLocks noGrp="1" noRot="1" noChangeAspect="1"/>
-          </p:cNvSpPr>
-          <p:nvPr>
-            <p:ph type="sldImg"/>
-          </p:nvPr>
-        </p:nvSpPr>
-        <p:spPr/>
-      </p:sp>
-      <p:sp>
-        <p:nvSpPr>
-          <p:cNvPr id="3" name="Notes Placeholder 2"/>
-          <p:cNvSpPr>
-            <a:spLocks noGrp="1"/>
-          </p:cNvSpPr>
-          <p:nvPr>
-            <p:ph type="body" idx="1"/>
-          </p:nvPr>
-        </p:nvSpPr>
-        <p:spPr/>
-        <p:txBody>
-          <a:bodyPr/>
-          <a:lstStyle/>
-          <a:p>
-            <a:r>
-              <a:rPr lang="en-GB" dirty="0"/>
-              <a:t>LabBench I/O</a:t>
-            </a:r>
-            <a:endParaRPr lang="en-DK" dirty="0"/>
-          </a:p>
-        </p:txBody>
-      </p:sp>
-      <p:sp>
-        <p:nvSpPr>
-          <p:cNvPr id="4" name="Slide Number Placeholder 3"/>
-          <p:cNvSpPr>
-            <a:spLocks noGrp="1"/>
-          </p:cNvSpPr>
-          <p:nvPr>
-            <p:ph type="sldNum" sz="quarter" idx="5"/>
-          </p:nvPr>
-        </p:nvSpPr>
-        <p:spPr/>
-        <p:txBody>
-          <a:bodyPr/>
-          <a:lstStyle/>
-          <a:p>
-            <a:fld id="{A20644BD-399A-490A-99CC-829CA96D1157}" type="slidenum">
-              <a:rPr lang="en-DK" smtClean="0"/>
-              <a:t>2</a:t>
-            </a:fld>
-            <a:endParaRPr lang="en-DK"/>
-          </a:p>
-        </p:txBody>
-      </p:sp>
-    </p:spTree>
-    <p:extLst>
-      <p:ext uri="{BB962C8B-B14F-4D97-AF65-F5344CB8AC3E}">
-        <p14:creationId xmlns:p14="http://schemas.microsoft.com/office/powerpoint/2010/main" val="99399054"/>
-      </p:ext>
-    </p:extLst>
-  </p:cSld>
-  <p:clrMapOvr>
-    <a:masterClrMapping/>
-  </p:clrMapOvr>
-</p:notes>
-</file>
-
 <file path=ppt/slideLayouts/slideLayout1.xml><?xml version="1.0" encoding="utf-8"?>
 <p:sldLayout xmlns:a="http://schemas.openxmlformats.org/drawingml/2006/main" xmlns:r="http://schemas.openxmlformats.org/officeDocument/2006/relationships" xmlns:p="http://schemas.openxmlformats.org/presentationml/2006/main" type="title" preserve="1">
   <p:cSld name="Title Slide">
@@ -978,7 +897,7 @@
           <a:p>
             <a:fld id="{F1465E3F-0B9F-47C9-9E08-5C827E095B3E}" type="datetimeFigureOut">
               <a:rPr lang="en-DK" smtClean="0"/>
-              <a:t>23/02/2026</a:t>
+              <a:t>26/02/2026</a:t>
             </a:fld>
             <a:endParaRPr lang="en-DK"/>
           </a:p>
@@ -1148,7 +1067,7 @@
           <a:p>
             <a:fld id="{F1465E3F-0B9F-47C9-9E08-5C827E095B3E}" type="datetimeFigureOut">
               <a:rPr lang="en-DK" smtClean="0"/>
-              <a:t>23/02/2026</a:t>
+              <a:t>26/02/2026</a:t>
             </a:fld>
             <a:endParaRPr lang="en-DK"/>
           </a:p>
@@ -1328,7 +1247,7 @@
           <a:p>
             <a:fld id="{F1465E3F-0B9F-47C9-9E08-5C827E095B3E}" type="datetimeFigureOut">
               <a:rPr lang="en-DK" smtClean="0"/>
-              <a:t>23/02/2026</a:t>
+              <a:t>26/02/2026</a:t>
             </a:fld>
             <a:endParaRPr lang="en-DK"/>
           </a:p>
@@ -1498,7 +1417,7 @@
           <a:p>
             <a:fld id="{F1465E3F-0B9F-47C9-9E08-5C827E095B3E}" type="datetimeFigureOut">
               <a:rPr lang="en-DK" smtClean="0"/>
-              <a:t>23/02/2026</a:t>
+              <a:t>26/02/2026</a:t>
             </a:fld>
             <a:endParaRPr lang="en-DK"/>
           </a:p>
@@ -1744,7 +1663,7 @@
           <a:p>
             <a:fld id="{F1465E3F-0B9F-47C9-9E08-5C827E095B3E}" type="datetimeFigureOut">
               <a:rPr lang="en-DK" smtClean="0"/>
-              <a:t>23/02/2026</a:t>
+              <a:t>26/02/2026</a:t>
             </a:fld>
             <a:endParaRPr lang="en-DK"/>
           </a:p>
@@ -1976,7 +1895,7 @@
           <a:p>
             <a:fld id="{F1465E3F-0B9F-47C9-9E08-5C827E095B3E}" type="datetimeFigureOut">
               <a:rPr lang="en-DK" smtClean="0"/>
-              <a:t>23/02/2026</a:t>
+              <a:t>26/02/2026</a:t>
             </a:fld>
             <a:endParaRPr lang="en-DK"/>
           </a:p>
@@ -2343,7 +2262,7 @@
           <a:p>
             <a:fld id="{F1465E3F-0B9F-47C9-9E08-5C827E095B3E}" type="datetimeFigureOut">
               <a:rPr lang="en-DK" smtClean="0"/>
-              <a:t>23/02/2026</a:t>
+              <a:t>26/02/2026</a:t>
             </a:fld>
             <a:endParaRPr lang="en-DK"/>
           </a:p>
@@ -2461,7 +2380,7 @@
           <a:p>
             <a:fld id="{F1465E3F-0B9F-47C9-9E08-5C827E095B3E}" type="datetimeFigureOut">
               <a:rPr lang="en-DK" smtClean="0"/>
-              <a:t>23/02/2026</a:t>
+              <a:t>26/02/2026</a:t>
             </a:fld>
             <a:endParaRPr lang="en-DK"/>
           </a:p>
@@ -2556,7 +2475,7 @@
           <a:p>
             <a:fld id="{F1465E3F-0B9F-47C9-9E08-5C827E095B3E}" type="datetimeFigureOut">
               <a:rPr lang="en-DK" smtClean="0"/>
-              <a:t>23/02/2026</a:t>
+              <a:t>26/02/2026</a:t>
             </a:fld>
             <a:endParaRPr lang="en-DK"/>
           </a:p>
@@ -2833,7 +2752,7 @@
           <a:p>
             <a:fld id="{F1465E3F-0B9F-47C9-9E08-5C827E095B3E}" type="datetimeFigureOut">
               <a:rPr lang="en-DK" smtClean="0"/>
-              <a:t>23/02/2026</a:t>
+              <a:t>26/02/2026</a:t>
             </a:fld>
             <a:endParaRPr lang="en-DK"/>
           </a:p>
@@ -3090,7 +3009,7 @@
           <a:p>
             <a:fld id="{F1465E3F-0B9F-47C9-9E08-5C827E095B3E}" type="datetimeFigureOut">
               <a:rPr lang="en-DK" smtClean="0"/>
-              <a:t>23/02/2026</a:t>
+              <a:t>26/02/2026</a:t>
             </a:fld>
             <a:endParaRPr lang="en-DK"/>
           </a:p>
@@ -3303,7 +3222,7 @@
           <a:p>
             <a:fld id="{F1465E3F-0B9F-47C9-9E08-5C827E095B3E}" type="datetimeFigureOut">
               <a:rPr lang="en-DK" smtClean="0"/>
-              <a:t>23/02/2026</a:t>
+              <a:t>26/02/2026</a:t>
             </a:fld>
             <a:endParaRPr lang="en-DK"/>
           </a:p>
@@ -3708,6 +3627,570 @@
           <a:chExt cx="0" cy="0"/>
         </a:xfrm>
       </p:grpSpPr>
+      <p:pic>
+        <p:nvPicPr>
+          <p:cNvPr id="3" name="Picture 2" descr="The image shows the LabBench Designer software interface, featuring a protocol for studying the correlation between Depression, Anxiety, Stress, and response inhibition using the DASS scale.&#10;&#10;AI-generated content may be incorrect.">
+            <a:extLst>
+              <a:ext uri="{FF2B5EF4-FFF2-40B4-BE49-F238E27FC236}">
+                <a16:creationId xmlns:a16="http://schemas.microsoft.com/office/drawing/2014/main" id="{DF0063AD-29A5-0EB6-D0B1-E694FF643F9E}"/>
+              </a:ext>
+            </a:extLst>
+          </p:cNvPr>
+          <p:cNvPicPr>
+            <a:picLocks noChangeAspect="1"/>
+          </p:cNvPicPr>
+          <p:nvPr/>
+        </p:nvPicPr>
+        <p:blipFill>
+          <a:blip r:embed="rId3"/>
+          <a:stretch>
+            <a:fillRect/>
+          </a:stretch>
+        </p:blipFill>
+        <p:spPr>
+          <a:xfrm>
+            <a:off x="7458805" y="6020010"/>
+            <a:ext cx="5400000" cy="2360192"/>
+          </a:xfrm>
+          <a:prstGeom prst="rect">
+            <a:avLst/>
+          </a:prstGeom>
+        </p:spPr>
+      </p:pic>
+      <p:sp>
+        <p:nvSpPr>
+          <p:cNvPr id="4" name="Oval 3">
+            <a:extLst>
+              <a:ext uri="{FF2B5EF4-FFF2-40B4-BE49-F238E27FC236}">
+                <a16:creationId xmlns:a16="http://schemas.microsoft.com/office/drawing/2014/main" id="{340F7FB0-320C-1BBD-CBCB-33EA0F5ABA51}"/>
+              </a:ext>
+            </a:extLst>
+          </p:cNvPr>
+          <p:cNvSpPr/>
+          <p:nvPr/>
+        </p:nvSpPr>
+        <p:spPr>
+          <a:xfrm>
+            <a:off x="12617450" y="6248400"/>
+            <a:ext cx="180000" cy="180000"/>
+          </a:xfrm>
+          <a:prstGeom prst="ellipse">
+            <a:avLst/>
+          </a:prstGeom>
+          <a:noFill/>
+          <a:ln>
+            <a:solidFill>
+              <a:srgbClr val="FF0000"/>
+            </a:solidFill>
+          </a:ln>
+        </p:spPr>
+        <p:style>
+          <a:lnRef idx="2">
+            <a:schemeClr val="accent1">
+              <a:shade val="15000"/>
+            </a:schemeClr>
+          </a:lnRef>
+          <a:fillRef idx="1">
+            <a:schemeClr val="accent1"/>
+          </a:fillRef>
+          <a:effectRef idx="0">
+            <a:schemeClr val="accent1"/>
+          </a:effectRef>
+          <a:fontRef idx="minor">
+            <a:schemeClr val="lt1"/>
+          </a:fontRef>
+        </p:style>
+        <p:txBody>
+          <a:bodyPr rtlCol="0" anchor="ctr"/>
+          <a:lstStyle/>
+          <a:p>
+            <a:pPr algn="ctr"/>
+            <a:endParaRPr lang="en-DK"/>
+          </a:p>
+        </p:txBody>
+      </p:sp>
+      <p:sp>
+        <p:nvSpPr>
+          <p:cNvPr id="5" name="Rectangle 4">
+            <a:extLst>
+              <a:ext uri="{FF2B5EF4-FFF2-40B4-BE49-F238E27FC236}">
+                <a16:creationId xmlns:a16="http://schemas.microsoft.com/office/drawing/2014/main" id="{33E4C72E-56FF-D993-69AC-B15D183C423E}"/>
+              </a:ext>
+            </a:extLst>
+          </p:cNvPr>
+          <p:cNvSpPr/>
+          <p:nvPr/>
+        </p:nvSpPr>
+        <p:spPr>
+          <a:xfrm>
+            <a:off x="7861300" y="6134100"/>
+            <a:ext cx="1911350" cy="2246102"/>
+          </a:xfrm>
+          <a:prstGeom prst="rect">
+            <a:avLst/>
+          </a:prstGeom>
+          <a:noFill/>
+          <a:ln>
+            <a:solidFill>
+              <a:srgbClr val="FF0000"/>
+            </a:solidFill>
+          </a:ln>
+        </p:spPr>
+        <p:style>
+          <a:lnRef idx="2">
+            <a:schemeClr val="accent1">
+              <a:shade val="15000"/>
+            </a:schemeClr>
+          </a:lnRef>
+          <a:fillRef idx="1">
+            <a:schemeClr val="accent1"/>
+          </a:fillRef>
+          <a:effectRef idx="0">
+            <a:schemeClr val="accent1"/>
+          </a:effectRef>
+          <a:fontRef idx="minor">
+            <a:schemeClr val="lt1"/>
+          </a:fontRef>
+        </p:style>
+        <p:txBody>
+          <a:bodyPr rtlCol="0" anchor="ctr"/>
+          <a:lstStyle/>
+          <a:p>
+            <a:pPr algn="ctr"/>
+            <a:endParaRPr lang="en-DK"/>
+          </a:p>
+        </p:txBody>
+      </p:sp>
+      <p:sp>
+        <p:nvSpPr>
+          <p:cNvPr id="6" name="Rectangle 5">
+            <a:extLst>
+              <a:ext uri="{FF2B5EF4-FFF2-40B4-BE49-F238E27FC236}">
+                <a16:creationId xmlns:a16="http://schemas.microsoft.com/office/drawing/2014/main" id="{0F1E6CB0-1753-A195-293F-76CE5C9E1CC7}"/>
+              </a:ext>
+            </a:extLst>
+          </p:cNvPr>
+          <p:cNvSpPr/>
+          <p:nvPr/>
+        </p:nvSpPr>
+        <p:spPr>
+          <a:xfrm>
+            <a:off x="9803606" y="6134100"/>
+            <a:ext cx="3011044" cy="2246102"/>
+          </a:xfrm>
+          <a:prstGeom prst="rect">
+            <a:avLst/>
+          </a:prstGeom>
+          <a:noFill/>
+          <a:ln>
+            <a:solidFill>
+              <a:srgbClr val="FF0000"/>
+            </a:solidFill>
+          </a:ln>
+        </p:spPr>
+        <p:style>
+          <a:lnRef idx="2">
+            <a:schemeClr val="accent1">
+              <a:shade val="15000"/>
+            </a:schemeClr>
+          </a:lnRef>
+          <a:fillRef idx="1">
+            <a:schemeClr val="accent1"/>
+          </a:fillRef>
+          <a:effectRef idx="0">
+            <a:schemeClr val="accent1"/>
+          </a:effectRef>
+          <a:fontRef idx="minor">
+            <a:schemeClr val="lt1"/>
+          </a:fontRef>
+        </p:style>
+        <p:txBody>
+          <a:bodyPr rtlCol="0" anchor="ctr"/>
+          <a:lstStyle/>
+          <a:p>
+            <a:pPr algn="ctr"/>
+            <a:endParaRPr lang="en-DK"/>
+          </a:p>
+        </p:txBody>
+      </p:sp>
+      <p:sp>
+        <p:nvSpPr>
+          <p:cNvPr id="7" name="Rectangle 6">
+            <a:extLst>
+              <a:ext uri="{FF2B5EF4-FFF2-40B4-BE49-F238E27FC236}">
+                <a16:creationId xmlns:a16="http://schemas.microsoft.com/office/drawing/2014/main" id="{7B059583-8CE5-D54E-7148-945A802CD1D0}"/>
+              </a:ext>
+            </a:extLst>
+          </p:cNvPr>
+          <p:cNvSpPr/>
+          <p:nvPr/>
+        </p:nvSpPr>
+        <p:spPr>
+          <a:xfrm>
+            <a:off x="9803606" y="6330950"/>
+            <a:ext cx="457200" cy="2049252"/>
+          </a:xfrm>
+          <a:prstGeom prst="rect">
+            <a:avLst/>
+          </a:prstGeom>
+          <a:noFill/>
+          <a:ln>
+            <a:solidFill>
+              <a:srgbClr val="FF0000"/>
+            </a:solidFill>
+          </a:ln>
+        </p:spPr>
+        <p:style>
+          <a:lnRef idx="2">
+            <a:schemeClr val="accent1">
+              <a:shade val="15000"/>
+            </a:schemeClr>
+          </a:lnRef>
+          <a:fillRef idx="1">
+            <a:schemeClr val="accent1"/>
+          </a:fillRef>
+          <a:effectRef idx="0">
+            <a:schemeClr val="accent1"/>
+          </a:effectRef>
+          <a:fontRef idx="minor">
+            <a:schemeClr val="lt1"/>
+          </a:fontRef>
+        </p:style>
+        <p:txBody>
+          <a:bodyPr rtlCol="0" anchor="ctr"/>
+          <a:lstStyle/>
+          <a:p>
+            <a:pPr algn="ctr"/>
+            <a:endParaRPr lang="en-DK"/>
+          </a:p>
+        </p:txBody>
+      </p:sp>
+      <p:sp>
+        <p:nvSpPr>
+          <p:cNvPr id="8" name="TextBox 7">
+            <a:extLst>
+              <a:ext uri="{FF2B5EF4-FFF2-40B4-BE49-F238E27FC236}">
+                <a16:creationId xmlns:a16="http://schemas.microsoft.com/office/drawing/2014/main" id="{0AF63C78-035E-11D2-2F03-11D4FFF9FB25}"/>
+              </a:ext>
+            </a:extLst>
+          </p:cNvPr>
+          <p:cNvSpPr txBox="1"/>
+          <p:nvPr/>
+        </p:nvSpPr>
+        <p:spPr>
+          <a:xfrm>
+            <a:off x="7784128" y="5359505"/>
+            <a:ext cx="2065694" cy="369332"/>
+          </a:xfrm>
+          <a:prstGeom prst="rect">
+            <a:avLst/>
+          </a:prstGeom>
+          <a:noFill/>
+        </p:spPr>
+        <p:txBody>
+          <a:bodyPr wrap="none" rtlCol="0">
+            <a:spAutoFit/>
+          </a:bodyPr>
+          <a:lstStyle/>
+          <a:p>
+            <a:r>
+              <a:rPr lang="en-US" dirty="0"/>
+              <a:t>List of experiments</a:t>
+            </a:r>
+            <a:endParaRPr lang="en-DK" dirty="0"/>
+          </a:p>
+        </p:txBody>
+      </p:sp>
+      <p:sp>
+        <p:nvSpPr>
+          <p:cNvPr id="9" name="TextBox 8">
+            <a:extLst>
+              <a:ext uri="{FF2B5EF4-FFF2-40B4-BE49-F238E27FC236}">
+                <a16:creationId xmlns:a16="http://schemas.microsoft.com/office/drawing/2014/main" id="{7983DE7A-B435-A1C4-774F-6A395BDE9F2F}"/>
+              </a:ext>
+            </a:extLst>
+          </p:cNvPr>
+          <p:cNvSpPr txBox="1"/>
+          <p:nvPr/>
+        </p:nvSpPr>
+        <p:spPr>
+          <a:xfrm>
+            <a:off x="9178318" y="8577052"/>
+            <a:ext cx="1707775" cy="369332"/>
+          </a:xfrm>
+          <a:prstGeom prst="rect">
+            <a:avLst/>
+          </a:prstGeom>
+          <a:noFill/>
+        </p:spPr>
+        <p:txBody>
+          <a:bodyPr wrap="none" rtlCol="0">
+            <a:spAutoFit/>
+          </a:bodyPr>
+          <a:lstStyle/>
+          <a:p>
+            <a:r>
+              <a:rPr lang="en-US" dirty="0"/>
+              <a:t>Panel selection</a:t>
+            </a:r>
+            <a:endParaRPr lang="en-DK" dirty="0"/>
+          </a:p>
+        </p:txBody>
+      </p:sp>
+      <p:sp>
+        <p:nvSpPr>
+          <p:cNvPr id="10" name="TextBox 9">
+            <a:extLst>
+              <a:ext uri="{FF2B5EF4-FFF2-40B4-BE49-F238E27FC236}">
+                <a16:creationId xmlns:a16="http://schemas.microsoft.com/office/drawing/2014/main" id="{AB3D1FFF-BEBC-7DAD-FE17-E3CFB3CD6614}"/>
+              </a:ext>
+            </a:extLst>
+          </p:cNvPr>
+          <p:cNvSpPr txBox="1"/>
+          <p:nvPr/>
+        </p:nvSpPr>
+        <p:spPr>
+          <a:xfrm>
+            <a:off x="10385542" y="5359505"/>
+            <a:ext cx="1847172" cy="369332"/>
+          </a:xfrm>
+          <a:prstGeom prst="rect">
+            <a:avLst/>
+          </a:prstGeom>
+          <a:noFill/>
+        </p:spPr>
+        <p:txBody>
+          <a:bodyPr wrap="none" rtlCol="0">
+            <a:spAutoFit/>
+          </a:bodyPr>
+          <a:lstStyle/>
+          <a:p>
+            <a:r>
+              <a:rPr lang="en-US" dirty="0"/>
+              <a:t>Experiment Page</a:t>
+            </a:r>
+            <a:endParaRPr lang="en-DK" dirty="0"/>
+          </a:p>
+        </p:txBody>
+      </p:sp>
+      <p:sp>
+        <p:nvSpPr>
+          <p:cNvPr id="11" name="TextBox 10">
+            <a:extLst>
+              <a:ext uri="{FF2B5EF4-FFF2-40B4-BE49-F238E27FC236}">
+                <a16:creationId xmlns:a16="http://schemas.microsoft.com/office/drawing/2014/main" id="{DCF1C7CA-15A6-42B2-1DC2-AE70C055D84F}"/>
+              </a:ext>
+            </a:extLst>
+          </p:cNvPr>
+          <p:cNvSpPr txBox="1"/>
+          <p:nvPr/>
+        </p:nvSpPr>
+        <p:spPr>
+          <a:xfrm>
+            <a:off x="13074650" y="6153734"/>
+            <a:ext cx="2013885" cy="369332"/>
+          </a:xfrm>
+          <a:prstGeom prst="rect">
+            <a:avLst/>
+          </a:prstGeom>
+          <a:noFill/>
+        </p:spPr>
+        <p:txBody>
+          <a:bodyPr wrap="none" rtlCol="0">
+            <a:spAutoFit/>
+          </a:bodyPr>
+          <a:lstStyle/>
+          <a:p>
+            <a:r>
+              <a:rPr lang="en-US" dirty="0"/>
+              <a:t>Delete experiment</a:t>
+            </a:r>
+            <a:endParaRPr lang="en-DK" dirty="0"/>
+          </a:p>
+        </p:txBody>
+      </p:sp>
+      <p:cxnSp>
+        <p:nvCxnSpPr>
+          <p:cNvPr id="13" name="Straight Arrow Connector 12">
+            <a:extLst>
+              <a:ext uri="{FF2B5EF4-FFF2-40B4-BE49-F238E27FC236}">
+                <a16:creationId xmlns:a16="http://schemas.microsoft.com/office/drawing/2014/main" id="{C7CB0F5D-59D1-A195-AFC8-BA5389883D23}"/>
+              </a:ext>
+            </a:extLst>
+          </p:cNvPr>
+          <p:cNvCxnSpPr>
+            <a:stCxn id="8" idx="2"/>
+            <a:endCxn id="5" idx="0"/>
+          </p:cNvCxnSpPr>
+          <p:nvPr/>
+        </p:nvCxnSpPr>
+        <p:spPr>
+          <a:xfrm>
+            <a:off x="8816975" y="5728837"/>
+            <a:ext cx="0" cy="405263"/>
+          </a:xfrm>
+          <a:prstGeom prst="straightConnector1">
+            <a:avLst/>
+          </a:prstGeom>
+          <a:ln w="28575">
+            <a:solidFill>
+              <a:srgbClr val="FF0000"/>
+            </a:solidFill>
+            <a:tailEnd type="triangle"/>
+          </a:ln>
+        </p:spPr>
+        <p:style>
+          <a:lnRef idx="2">
+            <a:schemeClr val="accent1"/>
+          </a:lnRef>
+          <a:fillRef idx="0">
+            <a:schemeClr val="accent1"/>
+          </a:fillRef>
+          <a:effectRef idx="1">
+            <a:schemeClr val="accent1"/>
+          </a:effectRef>
+          <a:fontRef idx="minor">
+            <a:schemeClr val="tx1"/>
+          </a:fontRef>
+        </p:style>
+      </p:cxnSp>
+      <p:cxnSp>
+        <p:nvCxnSpPr>
+          <p:cNvPr id="14" name="Straight Arrow Connector 13">
+            <a:extLst>
+              <a:ext uri="{FF2B5EF4-FFF2-40B4-BE49-F238E27FC236}">
+                <a16:creationId xmlns:a16="http://schemas.microsoft.com/office/drawing/2014/main" id="{E585756A-9B0E-DBA7-A30F-96C6C05170CA}"/>
+              </a:ext>
+            </a:extLst>
+          </p:cNvPr>
+          <p:cNvCxnSpPr>
+            <a:cxnSpLocks/>
+            <a:stCxn id="9" idx="0"/>
+            <a:endCxn id="7" idx="2"/>
+          </p:cNvCxnSpPr>
+          <p:nvPr/>
+        </p:nvCxnSpPr>
+        <p:spPr>
+          <a:xfrm flipV="1">
+            <a:off x="10032206" y="8380202"/>
+            <a:ext cx="0" cy="196850"/>
+          </a:xfrm>
+          <a:prstGeom prst="straightConnector1">
+            <a:avLst/>
+          </a:prstGeom>
+          <a:ln w="28575">
+            <a:solidFill>
+              <a:srgbClr val="FF0000"/>
+            </a:solidFill>
+            <a:tailEnd type="triangle"/>
+          </a:ln>
+        </p:spPr>
+        <p:style>
+          <a:lnRef idx="2">
+            <a:schemeClr val="accent1"/>
+          </a:lnRef>
+          <a:fillRef idx="0">
+            <a:schemeClr val="accent1"/>
+          </a:fillRef>
+          <a:effectRef idx="1">
+            <a:schemeClr val="accent1"/>
+          </a:effectRef>
+          <a:fontRef idx="minor">
+            <a:schemeClr val="tx1"/>
+          </a:fontRef>
+        </p:style>
+      </p:cxnSp>
+      <p:cxnSp>
+        <p:nvCxnSpPr>
+          <p:cNvPr id="15" name="Straight Arrow Connector 14">
+            <a:extLst>
+              <a:ext uri="{FF2B5EF4-FFF2-40B4-BE49-F238E27FC236}">
+                <a16:creationId xmlns:a16="http://schemas.microsoft.com/office/drawing/2014/main" id="{9330592C-7097-AFE7-8D46-208B72532F29}"/>
+              </a:ext>
+            </a:extLst>
+          </p:cNvPr>
+          <p:cNvCxnSpPr>
+            <a:cxnSpLocks/>
+            <a:stCxn id="11" idx="1"/>
+          </p:cNvCxnSpPr>
+          <p:nvPr/>
+        </p:nvCxnSpPr>
+        <p:spPr>
+          <a:xfrm flipH="1">
+            <a:off x="12797450" y="6338400"/>
+            <a:ext cx="277200" cy="0"/>
+          </a:xfrm>
+          <a:prstGeom prst="straightConnector1">
+            <a:avLst/>
+          </a:prstGeom>
+          <a:ln w="28575">
+            <a:solidFill>
+              <a:srgbClr val="FF0000"/>
+            </a:solidFill>
+            <a:tailEnd type="triangle"/>
+          </a:ln>
+        </p:spPr>
+        <p:style>
+          <a:lnRef idx="2">
+            <a:schemeClr val="accent1"/>
+          </a:lnRef>
+          <a:fillRef idx="0">
+            <a:schemeClr val="accent1"/>
+          </a:fillRef>
+          <a:effectRef idx="1">
+            <a:schemeClr val="accent1"/>
+          </a:effectRef>
+          <a:fontRef idx="minor">
+            <a:schemeClr val="tx1"/>
+          </a:fontRef>
+        </p:style>
+      </p:cxnSp>
+      <p:cxnSp>
+        <p:nvCxnSpPr>
+          <p:cNvPr id="16" name="Straight Arrow Connector 15">
+            <a:extLst>
+              <a:ext uri="{FF2B5EF4-FFF2-40B4-BE49-F238E27FC236}">
+                <a16:creationId xmlns:a16="http://schemas.microsoft.com/office/drawing/2014/main" id="{9688D85F-9C33-4E52-D5F6-D9E9B7BB4AE1}"/>
+              </a:ext>
+            </a:extLst>
+          </p:cNvPr>
+          <p:cNvCxnSpPr>
+            <a:cxnSpLocks/>
+            <a:stCxn id="10" idx="2"/>
+            <a:endCxn id="6" idx="0"/>
+          </p:cNvCxnSpPr>
+          <p:nvPr/>
+        </p:nvCxnSpPr>
+        <p:spPr>
+          <a:xfrm>
+            <a:off x="11309128" y="5728837"/>
+            <a:ext cx="0" cy="405263"/>
+          </a:xfrm>
+          <a:prstGeom prst="straightConnector1">
+            <a:avLst/>
+          </a:prstGeom>
+          <a:ln w="28575">
+            <a:solidFill>
+              <a:srgbClr val="FF0000"/>
+            </a:solidFill>
+            <a:tailEnd type="triangle"/>
+          </a:ln>
+        </p:spPr>
+        <p:style>
+          <a:lnRef idx="2">
+            <a:schemeClr val="accent1"/>
+          </a:lnRef>
+          <a:fillRef idx="0">
+            <a:schemeClr val="accent1"/>
+          </a:fillRef>
+          <a:effectRef idx="1">
+            <a:schemeClr val="accent1"/>
+          </a:effectRef>
+          <a:fontRef idx="minor">
+            <a:schemeClr val="tx1"/>
+          </a:fontRef>
+        </p:style>
+      </p:cxnSp>
     </p:spTree>
     <p:extLst>
       <p:ext uri="{BB962C8B-B14F-4D97-AF65-F5344CB8AC3E}">
@@ -3738,10 +4221,1646 @@
           <a:chExt cx="0" cy="0"/>
         </a:xfrm>
       </p:grpSpPr>
+      <p:pic>
+        <p:nvPicPr>
+          <p:cNvPr id="5" name="Picture 4" descr="The image displays a LabBench protocol setup for studying the correlation between depression, anxiety, and stress using the DASS scale, and response inhibition with the Stop-Signal Task.&#10;&#10;AI-generated content may be incorrect.">
+            <a:extLst>
+              <a:ext uri="{FF2B5EF4-FFF2-40B4-BE49-F238E27FC236}">
+                <a16:creationId xmlns:a16="http://schemas.microsoft.com/office/drawing/2014/main" id="{801D8AA3-6539-406C-EB81-3D658DBEC791}"/>
+              </a:ext>
+            </a:extLst>
+          </p:cNvPr>
+          <p:cNvPicPr>
+            <a:picLocks noChangeAspect="1"/>
+          </p:cNvPicPr>
+          <p:nvPr/>
+        </p:nvPicPr>
+        <p:blipFill>
+          <a:blip r:embed="rId2"/>
+          <a:srcRect b="48330"/>
+          <a:stretch>
+            <a:fillRect/>
+          </a:stretch>
+        </p:blipFill>
+        <p:spPr>
+          <a:xfrm>
+            <a:off x="7387324" y="6147935"/>
+            <a:ext cx="5400000" cy="3100205"/>
+          </a:xfrm>
+          <a:prstGeom prst="rect">
+            <a:avLst/>
+          </a:prstGeom>
+        </p:spPr>
+      </p:pic>
+      <p:sp>
+        <p:nvSpPr>
+          <p:cNvPr id="6" name="Rectangle 5">
+            <a:extLst>
+              <a:ext uri="{FF2B5EF4-FFF2-40B4-BE49-F238E27FC236}">
+                <a16:creationId xmlns:a16="http://schemas.microsoft.com/office/drawing/2014/main" id="{F539A082-DE34-87C2-8AEE-FF66AA9511DA}"/>
+              </a:ext>
+            </a:extLst>
+          </p:cNvPr>
+          <p:cNvSpPr/>
+          <p:nvPr/>
+        </p:nvSpPr>
+        <p:spPr>
+          <a:xfrm>
+            <a:off x="8202168" y="6454140"/>
+            <a:ext cx="1885156" cy="241300"/>
+          </a:xfrm>
+          <a:prstGeom prst="rect">
+            <a:avLst/>
+          </a:prstGeom>
+          <a:noFill/>
+          <a:ln>
+            <a:solidFill>
+              <a:srgbClr val="FF0000"/>
+            </a:solidFill>
+          </a:ln>
+        </p:spPr>
+        <p:style>
+          <a:lnRef idx="2">
+            <a:schemeClr val="accent1">
+              <a:shade val="15000"/>
+            </a:schemeClr>
+          </a:lnRef>
+          <a:fillRef idx="1">
+            <a:schemeClr val="accent1"/>
+          </a:fillRef>
+          <a:effectRef idx="0">
+            <a:schemeClr val="accent1"/>
+          </a:effectRef>
+          <a:fontRef idx="minor">
+            <a:schemeClr val="lt1"/>
+          </a:fontRef>
+        </p:style>
+        <p:txBody>
+          <a:bodyPr rtlCol="0" anchor="ctr"/>
+          <a:lstStyle/>
+          <a:p>
+            <a:pPr algn="ctr"/>
+            <a:endParaRPr lang="en-DK"/>
+          </a:p>
+        </p:txBody>
+      </p:sp>
+      <p:sp>
+        <p:nvSpPr>
+          <p:cNvPr id="7" name="TextBox 6">
+            <a:extLst>
+              <a:ext uri="{FF2B5EF4-FFF2-40B4-BE49-F238E27FC236}">
+                <a16:creationId xmlns:a16="http://schemas.microsoft.com/office/drawing/2014/main" id="{E1596019-A031-4F16-A352-E07B3626E1A0}"/>
+              </a:ext>
+            </a:extLst>
+          </p:cNvPr>
+          <p:cNvSpPr txBox="1"/>
+          <p:nvPr/>
+        </p:nvSpPr>
+        <p:spPr>
+          <a:xfrm>
+            <a:off x="7925918" y="5625501"/>
+            <a:ext cx="2437655" cy="369332"/>
+          </a:xfrm>
+          <a:prstGeom prst="rect">
+            <a:avLst/>
+          </a:prstGeom>
+          <a:noFill/>
+        </p:spPr>
+        <p:txBody>
+          <a:bodyPr wrap="none" rtlCol="0">
+            <a:spAutoFit/>
+          </a:bodyPr>
+          <a:lstStyle/>
+          <a:p>
+            <a:r>
+              <a:rPr lang="en-US" dirty="0"/>
+              <a:t>Print and view controls</a:t>
+            </a:r>
+            <a:endParaRPr lang="en-DK" dirty="0"/>
+          </a:p>
+        </p:txBody>
+      </p:sp>
+      <p:cxnSp>
+        <p:nvCxnSpPr>
+          <p:cNvPr id="9" name="Straight Arrow Connector 8">
+            <a:extLst>
+              <a:ext uri="{FF2B5EF4-FFF2-40B4-BE49-F238E27FC236}">
+                <a16:creationId xmlns:a16="http://schemas.microsoft.com/office/drawing/2014/main" id="{EFBBA6A6-0C1F-E501-E4EE-3E65E1D9794D}"/>
+              </a:ext>
+            </a:extLst>
+          </p:cNvPr>
+          <p:cNvCxnSpPr>
+            <a:stCxn id="7" idx="2"/>
+            <a:endCxn id="6" idx="0"/>
+          </p:cNvCxnSpPr>
+          <p:nvPr/>
+        </p:nvCxnSpPr>
+        <p:spPr>
+          <a:xfrm>
+            <a:off x="9144746" y="5994833"/>
+            <a:ext cx="0" cy="459307"/>
+          </a:xfrm>
+          <a:prstGeom prst="straightConnector1">
+            <a:avLst/>
+          </a:prstGeom>
+          <a:ln w="28575">
+            <a:solidFill>
+              <a:srgbClr val="FF0000"/>
+            </a:solidFill>
+            <a:tailEnd type="triangle"/>
+          </a:ln>
+        </p:spPr>
+        <p:style>
+          <a:lnRef idx="2">
+            <a:schemeClr val="accent1"/>
+          </a:lnRef>
+          <a:fillRef idx="0">
+            <a:schemeClr val="accent1"/>
+          </a:fillRef>
+          <a:effectRef idx="1">
+            <a:schemeClr val="accent1"/>
+          </a:effectRef>
+          <a:fontRef idx="minor">
+            <a:schemeClr val="tx1"/>
+          </a:fontRef>
+        </p:style>
+      </p:cxnSp>
     </p:spTree>
     <p:extLst>
       <p:ext uri="{BB962C8B-B14F-4D97-AF65-F5344CB8AC3E}">
-        <p14:creationId xmlns:p14="http://schemas.microsoft.com/office/powerpoint/2010/main" val="2435479675"/>
+        <p14:creationId xmlns:p14="http://schemas.microsoft.com/office/powerpoint/2010/main" val="600685456"/>
+      </p:ext>
+    </p:extLst>
+  </p:cSld>
+  <p:clrMapOvr>
+    <a:masterClrMapping/>
+  </p:clrMapOvr>
+</p:sld>
+</file>
+
+<file path=ppt/slides/slide3.xml><?xml version="1.0" encoding="utf-8"?>
+<p:sld xmlns:a="http://schemas.openxmlformats.org/drawingml/2006/main" xmlns:r="http://schemas.openxmlformats.org/officeDocument/2006/relationships" xmlns:p="http://schemas.openxmlformats.org/presentationml/2006/main">
+  <p:cSld>
+    <p:spTree>
+      <p:nvGrpSpPr>
+        <p:cNvPr id="1" name=""/>
+        <p:cNvGrpSpPr/>
+        <p:nvPr/>
+      </p:nvGrpSpPr>
+      <p:grpSpPr>
+        <a:xfrm>
+          <a:off x="0" y="0"/>
+          <a:ext cx="0" cy="0"/>
+          <a:chOff x="0" y="0"/>
+          <a:chExt cx="0" cy="0"/>
+        </a:xfrm>
+      </p:grpSpPr>
+      <p:pic>
+        <p:nvPicPr>
+          <p:cNvPr id="3" name="Picture 2" descr="The image displays a user interface for a LabBench system, featuring sections for participant ID input, protocol setup, data, investigator roles, and options for LabBench I/O and display functionalities, along with a post-session action to export data to a CSV file.&#10;&#10;AI-generated content may be incorrect.">
+            <a:extLst>
+              <a:ext uri="{FF2B5EF4-FFF2-40B4-BE49-F238E27FC236}">
+                <a16:creationId xmlns:a16="http://schemas.microsoft.com/office/drawing/2014/main" id="{25252F4B-C743-95E9-6147-D23297C8B31F}"/>
+              </a:ext>
+            </a:extLst>
+          </p:cNvPr>
+          <p:cNvPicPr>
+            <a:picLocks noChangeAspect="1"/>
+          </p:cNvPicPr>
+          <p:nvPr/>
+        </p:nvPicPr>
+        <p:blipFill>
+          <a:blip r:embed="rId2"/>
+          <a:stretch>
+            <a:fillRect/>
+          </a:stretch>
+        </p:blipFill>
+        <p:spPr>
+          <a:xfrm>
+            <a:off x="8100556" y="3392664"/>
+            <a:ext cx="5400000" cy="6065217"/>
+          </a:xfrm>
+          <a:prstGeom prst="rect">
+            <a:avLst/>
+          </a:prstGeom>
+        </p:spPr>
+      </p:pic>
+      <p:sp>
+        <p:nvSpPr>
+          <p:cNvPr id="4" name="Oval 3">
+            <a:extLst>
+              <a:ext uri="{FF2B5EF4-FFF2-40B4-BE49-F238E27FC236}">
+                <a16:creationId xmlns:a16="http://schemas.microsoft.com/office/drawing/2014/main" id="{0117CACF-4302-F450-14A7-35679634ABF5}"/>
+              </a:ext>
+            </a:extLst>
+          </p:cNvPr>
+          <p:cNvSpPr/>
+          <p:nvPr/>
+        </p:nvSpPr>
+        <p:spPr>
+          <a:xfrm>
+            <a:off x="12979400" y="4117366"/>
+            <a:ext cx="288000" cy="288000"/>
+          </a:xfrm>
+          <a:prstGeom prst="ellipse">
+            <a:avLst/>
+          </a:prstGeom>
+          <a:noFill/>
+          <a:ln>
+            <a:solidFill>
+              <a:srgbClr val="FF0000"/>
+            </a:solidFill>
+          </a:ln>
+        </p:spPr>
+        <p:style>
+          <a:lnRef idx="2">
+            <a:schemeClr val="accent1">
+              <a:shade val="15000"/>
+            </a:schemeClr>
+          </a:lnRef>
+          <a:fillRef idx="1">
+            <a:schemeClr val="accent1"/>
+          </a:fillRef>
+          <a:effectRef idx="0">
+            <a:schemeClr val="accent1"/>
+          </a:effectRef>
+          <a:fontRef idx="minor">
+            <a:schemeClr val="lt1"/>
+          </a:fontRef>
+        </p:style>
+        <p:txBody>
+          <a:bodyPr rtlCol="0" anchor="ctr"/>
+          <a:lstStyle/>
+          <a:p>
+            <a:pPr algn="ctr"/>
+            <a:endParaRPr lang="en-DK"/>
+          </a:p>
+        </p:txBody>
+      </p:sp>
+      <p:sp>
+        <p:nvSpPr>
+          <p:cNvPr id="5" name="Oval 4">
+            <a:extLst>
+              <a:ext uri="{FF2B5EF4-FFF2-40B4-BE49-F238E27FC236}">
+                <a16:creationId xmlns:a16="http://schemas.microsoft.com/office/drawing/2014/main" id="{524CD6AB-79B1-D694-0C34-E4A2BA3E7C89}"/>
+              </a:ext>
+            </a:extLst>
+          </p:cNvPr>
+          <p:cNvSpPr/>
+          <p:nvPr/>
+        </p:nvSpPr>
+        <p:spPr>
+          <a:xfrm>
+            <a:off x="12979400" y="5082536"/>
+            <a:ext cx="288000" cy="288000"/>
+          </a:xfrm>
+          <a:prstGeom prst="ellipse">
+            <a:avLst/>
+          </a:prstGeom>
+          <a:noFill/>
+          <a:ln>
+            <a:solidFill>
+              <a:srgbClr val="FF0000"/>
+            </a:solidFill>
+          </a:ln>
+        </p:spPr>
+        <p:style>
+          <a:lnRef idx="2">
+            <a:schemeClr val="accent1">
+              <a:shade val="15000"/>
+            </a:schemeClr>
+          </a:lnRef>
+          <a:fillRef idx="1">
+            <a:schemeClr val="accent1"/>
+          </a:fillRef>
+          <a:effectRef idx="0">
+            <a:schemeClr val="accent1"/>
+          </a:effectRef>
+          <a:fontRef idx="minor">
+            <a:schemeClr val="lt1"/>
+          </a:fontRef>
+        </p:style>
+        <p:txBody>
+          <a:bodyPr rtlCol="0" anchor="ctr"/>
+          <a:lstStyle/>
+          <a:p>
+            <a:pPr algn="ctr"/>
+            <a:endParaRPr lang="en-DK"/>
+          </a:p>
+        </p:txBody>
+      </p:sp>
+      <p:sp>
+        <p:nvSpPr>
+          <p:cNvPr id="6" name="Oval 5">
+            <a:extLst>
+              <a:ext uri="{FF2B5EF4-FFF2-40B4-BE49-F238E27FC236}">
+                <a16:creationId xmlns:a16="http://schemas.microsoft.com/office/drawing/2014/main" id="{7C403844-C2ED-605D-AB35-4924B85196CC}"/>
+              </a:ext>
+            </a:extLst>
+          </p:cNvPr>
+          <p:cNvSpPr/>
+          <p:nvPr/>
+        </p:nvSpPr>
+        <p:spPr>
+          <a:xfrm>
+            <a:off x="12975300" y="6037056"/>
+            <a:ext cx="288000" cy="288000"/>
+          </a:xfrm>
+          <a:prstGeom prst="ellipse">
+            <a:avLst/>
+          </a:prstGeom>
+          <a:noFill/>
+          <a:ln>
+            <a:solidFill>
+              <a:srgbClr val="FF0000"/>
+            </a:solidFill>
+          </a:ln>
+        </p:spPr>
+        <p:style>
+          <a:lnRef idx="2">
+            <a:schemeClr val="accent1">
+              <a:shade val="15000"/>
+            </a:schemeClr>
+          </a:lnRef>
+          <a:fillRef idx="1">
+            <a:schemeClr val="accent1"/>
+          </a:fillRef>
+          <a:effectRef idx="0">
+            <a:schemeClr val="accent1"/>
+          </a:effectRef>
+          <a:fontRef idx="minor">
+            <a:schemeClr val="lt1"/>
+          </a:fontRef>
+        </p:style>
+        <p:txBody>
+          <a:bodyPr rtlCol="0" anchor="ctr"/>
+          <a:lstStyle/>
+          <a:p>
+            <a:pPr algn="ctr"/>
+            <a:endParaRPr lang="en-DK"/>
+          </a:p>
+        </p:txBody>
+      </p:sp>
+      <p:sp>
+        <p:nvSpPr>
+          <p:cNvPr id="7" name="Oval 6">
+            <a:extLst>
+              <a:ext uri="{FF2B5EF4-FFF2-40B4-BE49-F238E27FC236}">
+                <a16:creationId xmlns:a16="http://schemas.microsoft.com/office/drawing/2014/main" id="{319E845C-D64B-B587-5F6D-315D8C17B475}"/>
+              </a:ext>
+            </a:extLst>
+          </p:cNvPr>
+          <p:cNvSpPr/>
+          <p:nvPr/>
+        </p:nvSpPr>
+        <p:spPr>
+          <a:xfrm>
+            <a:off x="12624000" y="8682740"/>
+            <a:ext cx="288000" cy="288000"/>
+          </a:xfrm>
+          <a:prstGeom prst="ellipse">
+            <a:avLst/>
+          </a:prstGeom>
+          <a:noFill/>
+          <a:ln>
+            <a:solidFill>
+              <a:srgbClr val="FF0000"/>
+            </a:solidFill>
+          </a:ln>
+        </p:spPr>
+        <p:style>
+          <a:lnRef idx="2">
+            <a:schemeClr val="accent1">
+              <a:shade val="15000"/>
+            </a:schemeClr>
+          </a:lnRef>
+          <a:fillRef idx="1">
+            <a:schemeClr val="accent1"/>
+          </a:fillRef>
+          <a:effectRef idx="0">
+            <a:schemeClr val="accent1"/>
+          </a:effectRef>
+          <a:fontRef idx="minor">
+            <a:schemeClr val="lt1"/>
+          </a:fontRef>
+        </p:style>
+        <p:txBody>
+          <a:bodyPr rtlCol="0" anchor="ctr"/>
+          <a:lstStyle/>
+          <a:p>
+            <a:pPr algn="ctr"/>
+            <a:endParaRPr lang="en-DK"/>
+          </a:p>
+        </p:txBody>
+      </p:sp>
+      <p:sp>
+        <p:nvSpPr>
+          <p:cNvPr id="8" name="Oval 7">
+            <a:extLst>
+              <a:ext uri="{FF2B5EF4-FFF2-40B4-BE49-F238E27FC236}">
+                <a16:creationId xmlns:a16="http://schemas.microsoft.com/office/drawing/2014/main" id="{F7537E0D-F78B-9AA6-71A5-FD1848939068}"/>
+              </a:ext>
+            </a:extLst>
+          </p:cNvPr>
+          <p:cNvSpPr/>
+          <p:nvPr/>
+        </p:nvSpPr>
+        <p:spPr>
+          <a:xfrm>
+            <a:off x="12945800" y="8682740"/>
+            <a:ext cx="288000" cy="288000"/>
+          </a:xfrm>
+          <a:prstGeom prst="ellipse">
+            <a:avLst/>
+          </a:prstGeom>
+          <a:noFill/>
+          <a:ln>
+            <a:solidFill>
+              <a:srgbClr val="FF0000"/>
+            </a:solidFill>
+          </a:ln>
+        </p:spPr>
+        <p:style>
+          <a:lnRef idx="2">
+            <a:schemeClr val="accent1">
+              <a:shade val="15000"/>
+            </a:schemeClr>
+          </a:lnRef>
+          <a:fillRef idx="1">
+            <a:schemeClr val="accent1"/>
+          </a:fillRef>
+          <a:effectRef idx="0">
+            <a:schemeClr val="accent1"/>
+          </a:effectRef>
+          <a:fontRef idx="minor">
+            <a:schemeClr val="lt1"/>
+          </a:fontRef>
+        </p:style>
+        <p:txBody>
+          <a:bodyPr rtlCol="0" anchor="ctr"/>
+          <a:lstStyle/>
+          <a:p>
+            <a:pPr algn="ctr"/>
+            <a:endParaRPr lang="en-DK"/>
+          </a:p>
+        </p:txBody>
+      </p:sp>
+      <p:sp>
+        <p:nvSpPr>
+          <p:cNvPr id="9" name="Oval 8">
+            <a:extLst>
+              <a:ext uri="{FF2B5EF4-FFF2-40B4-BE49-F238E27FC236}">
+                <a16:creationId xmlns:a16="http://schemas.microsoft.com/office/drawing/2014/main" id="{867C4D9E-121B-83DC-05D3-721565FCABFE}"/>
+              </a:ext>
+            </a:extLst>
+          </p:cNvPr>
+          <p:cNvSpPr/>
+          <p:nvPr/>
+        </p:nvSpPr>
+        <p:spPr>
+          <a:xfrm>
+            <a:off x="13002970" y="6582648"/>
+            <a:ext cx="232660" cy="232660"/>
+          </a:xfrm>
+          <a:prstGeom prst="ellipse">
+            <a:avLst/>
+          </a:prstGeom>
+          <a:noFill/>
+          <a:ln>
+            <a:solidFill>
+              <a:srgbClr val="FF0000"/>
+            </a:solidFill>
+          </a:ln>
+        </p:spPr>
+        <p:style>
+          <a:lnRef idx="2">
+            <a:schemeClr val="accent1">
+              <a:shade val="15000"/>
+            </a:schemeClr>
+          </a:lnRef>
+          <a:fillRef idx="1">
+            <a:schemeClr val="accent1"/>
+          </a:fillRef>
+          <a:effectRef idx="0">
+            <a:schemeClr val="accent1"/>
+          </a:effectRef>
+          <a:fontRef idx="minor">
+            <a:schemeClr val="lt1"/>
+          </a:fontRef>
+        </p:style>
+        <p:txBody>
+          <a:bodyPr rtlCol="0" anchor="ctr"/>
+          <a:lstStyle/>
+          <a:p>
+            <a:pPr algn="ctr"/>
+            <a:endParaRPr lang="en-DK"/>
+          </a:p>
+        </p:txBody>
+      </p:sp>
+      <p:sp>
+        <p:nvSpPr>
+          <p:cNvPr id="10" name="Rectangle: Rounded Corners 9">
+            <a:extLst>
+              <a:ext uri="{FF2B5EF4-FFF2-40B4-BE49-F238E27FC236}">
+                <a16:creationId xmlns:a16="http://schemas.microsoft.com/office/drawing/2014/main" id="{B19BF603-2B5E-767B-2D09-8A3250C6412B}"/>
+              </a:ext>
+            </a:extLst>
+          </p:cNvPr>
+          <p:cNvSpPr/>
+          <p:nvPr/>
+        </p:nvSpPr>
+        <p:spPr>
+          <a:xfrm>
+            <a:off x="12849224" y="5462423"/>
+            <a:ext cx="384575" cy="237422"/>
+          </a:xfrm>
+          <a:prstGeom prst="roundRect">
+            <a:avLst/>
+          </a:prstGeom>
+          <a:noFill/>
+          <a:ln>
+            <a:solidFill>
+              <a:srgbClr val="FF0000"/>
+            </a:solidFill>
+          </a:ln>
+        </p:spPr>
+        <p:style>
+          <a:lnRef idx="2">
+            <a:schemeClr val="accent1">
+              <a:shade val="15000"/>
+            </a:schemeClr>
+          </a:lnRef>
+          <a:fillRef idx="1">
+            <a:schemeClr val="accent1"/>
+          </a:fillRef>
+          <a:effectRef idx="0">
+            <a:schemeClr val="accent1"/>
+          </a:effectRef>
+          <a:fontRef idx="minor">
+            <a:schemeClr val="lt1"/>
+          </a:fontRef>
+        </p:style>
+        <p:txBody>
+          <a:bodyPr rtlCol="0" anchor="ctr"/>
+          <a:lstStyle/>
+          <a:p>
+            <a:pPr algn="ctr"/>
+            <a:endParaRPr lang="en-DK"/>
+          </a:p>
+        </p:txBody>
+      </p:sp>
+      <p:sp>
+        <p:nvSpPr>
+          <p:cNvPr id="11" name="TextBox 10">
+            <a:extLst>
+              <a:ext uri="{FF2B5EF4-FFF2-40B4-BE49-F238E27FC236}">
+                <a16:creationId xmlns:a16="http://schemas.microsoft.com/office/drawing/2014/main" id="{B146DB9D-6653-1238-E4BF-C2D52BC1A0CF}"/>
+              </a:ext>
+            </a:extLst>
+          </p:cNvPr>
+          <p:cNvSpPr txBox="1"/>
+          <p:nvPr/>
+        </p:nvSpPr>
+        <p:spPr>
+          <a:xfrm>
+            <a:off x="13830300" y="4076700"/>
+            <a:ext cx="3317383" cy="369332"/>
+          </a:xfrm>
+          <a:prstGeom prst="rect">
+            <a:avLst/>
+          </a:prstGeom>
+          <a:noFill/>
+        </p:spPr>
+        <p:txBody>
+          <a:bodyPr wrap="none" rtlCol="0">
+            <a:spAutoFit/>
+          </a:bodyPr>
+          <a:lstStyle/>
+          <a:p>
+            <a:r>
+              <a:rPr lang="en-US" dirty="0"/>
+              <a:t>Configure participant validation</a:t>
+            </a:r>
+            <a:endParaRPr lang="en-DK" dirty="0"/>
+          </a:p>
+        </p:txBody>
+      </p:sp>
+      <p:sp>
+        <p:nvSpPr>
+          <p:cNvPr id="12" name="TextBox 11">
+            <a:extLst>
+              <a:ext uri="{FF2B5EF4-FFF2-40B4-BE49-F238E27FC236}">
+                <a16:creationId xmlns:a16="http://schemas.microsoft.com/office/drawing/2014/main" id="{9AF4273A-6D1C-C7DD-969A-A5C7D3CA00E4}"/>
+              </a:ext>
+            </a:extLst>
+          </p:cNvPr>
+          <p:cNvSpPr txBox="1"/>
+          <p:nvPr/>
+        </p:nvSpPr>
+        <p:spPr>
+          <a:xfrm>
+            <a:off x="13830300" y="5041870"/>
+            <a:ext cx="1701235" cy="369332"/>
+          </a:xfrm>
+          <a:prstGeom prst="rect">
+            <a:avLst/>
+          </a:prstGeom>
+          <a:noFill/>
+        </p:spPr>
+        <p:txBody>
+          <a:bodyPr wrap="none" rtlCol="0">
+            <a:spAutoFit/>
+          </a:bodyPr>
+          <a:lstStyle/>
+          <a:p>
+            <a:r>
+              <a:rPr lang="en-US" dirty="0"/>
+              <a:t>Add researcher</a:t>
+            </a:r>
+            <a:endParaRPr lang="en-DK" dirty="0"/>
+          </a:p>
+        </p:txBody>
+      </p:sp>
+      <p:sp>
+        <p:nvSpPr>
+          <p:cNvPr id="13" name="TextBox 12">
+            <a:extLst>
+              <a:ext uri="{FF2B5EF4-FFF2-40B4-BE49-F238E27FC236}">
+                <a16:creationId xmlns:a16="http://schemas.microsoft.com/office/drawing/2014/main" id="{67266C6D-6999-9D61-361F-A23444CE6919}"/>
+              </a:ext>
+            </a:extLst>
+          </p:cNvPr>
+          <p:cNvSpPr txBox="1"/>
+          <p:nvPr/>
+        </p:nvSpPr>
+        <p:spPr>
+          <a:xfrm>
+            <a:off x="13830300" y="5396468"/>
+            <a:ext cx="2111925" cy="369332"/>
+          </a:xfrm>
+          <a:prstGeom prst="rect">
+            <a:avLst/>
+          </a:prstGeom>
+          <a:noFill/>
+        </p:spPr>
+        <p:txBody>
+          <a:bodyPr wrap="none" rtlCol="0">
+            <a:spAutoFit/>
+          </a:bodyPr>
+          <a:lstStyle/>
+          <a:p>
+            <a:r>
+              <a:rPr lang="en-US" dirty="0"/>
+              <a:t>Remove researcher</a:t>
+            </a:r>
+            <a:endParaRPr lang="en-DK" dirty="0"/>
+          </a:p>
+        </p:txBody>
+      </p:sp>
+      <p:sp>
+        <p:nvSpPr>
+          <p:cNvPr id="14" name="TextBox 13">
+            <a:extLst>
+              <a:ext uri="{FF2B5EF4-FFF2-40B4-BE49-F238E27FC236}">
+                <a16:creationId xmlns:a16="http://schemas.microsoft.com/office/drawing/2014/main" id="{07692C0E-702E-DBA9-9F3F-0C46269C1244}"/>
+              </a:ext>
+            </a:extLst>
+          </p:cNvPr>
+          <p:cNvSpPr txBox="1"/>
+          <p:nvPr/>
+        </p:nvSpPr>
+        <p:spPr>
+          <a:xfrm>
+            <a:off x="13830300" y="5996390"/>
+            <a:ext cx="1654299" cy="369332"/>
+          </a:xfrm>
+          <a:prstGeom prst="rect">
+            <a:avLst/>
+          </a:prstGeom>
+          <a:noFill/>
+        </p:spPr>
+        <p:txBody>
+          <a:bodyPr wrap="none" rtlCol="0">
+            <a:spAutoFit/>
+          </a:bodyPr>
+          <a:lstStyle/>
+          <a:p>
+            <a:r>
+              <a:rPr lang="en-US" dirty="0"/>
+              <a:t>Assign devices</a:t>
+            </a:r>
+            <a:endParaRPr lang="en-DK" dirty="0"/>
+          </a:p>
+        </p:txBody>
+      </p:sp>
+      <p:sp>
+        <p:nvSpPr>
+          <p:cNvPr id="15" name="TextBox 14">
+            <a:extLst>
+              <a:ext uri="{FF2B5EF4-FFF2-40B4-BE49-F238E27FC236}">
+                <a16:creationId xmlns:a16="http://schemas.microsoft.com/office/drawing/2014/main" id="{F74D909D-626A-0B01-FA3D-532066267861}"/>
+              </a:ext>
+            </a:extLst>
+          </p:cNvPr>
+          <p:cNvSpPr txBox="1"/>
+          <p:nvPr/>
+        </p:nvSpPr>
+        <p:spPr>
+          <a:xfrm>
+            <a:off x="13830300" y="6514312"/>
+            <a:ext cx="1858009" cy="369332"/>
+          </a:xfrm>
+          <a:prstGeom prst="rect">
+            <a:avLst/>
+          </a:prstGeom>
+          <a:noFill/>
+        </p:spPr>
+        <p:txBody>
+          <a:bodyPr wrap="none" rtlCol="0">
+            <a:spAutoFit/>
+          </a:bodyPr>
+          <a:lstStyle/>
+          <a:p>
+            <a:r>
+              <a:rPr lang="en-US" dirty="0"/>
+              <a:t>Configure device</a:t>
+            </a:r>
+            <a:endParaRPr lang="en-DK" dirty="0"/>
+          </a:p>
+        </p:txBody>
+      </p:sp>
+      <p:sp>
+        <p:nvSpPr>
+          <p:cNvPr id="16" name="TextBox 15">
+            <a:extLst>
+              <a:ext uri="{FF2B5EF4-FFF2-40B4-BE49-F238E27FC236}">
+                <a16:creationId xmlns:a16="http://schemas.microsoft.com/office/drawing/2014/main" id="{CF9E0241-FE3F-5EF6-E70B-6FFCC7A0F91E}"/>
+              </a:ext>
+            </a:extLst>
+          </p:cNvPr>
+          <p:cNvSpPr txBox="1"/>
+          <p:nvPr/>
+        </p:nvSpPr>
+        <p:spPr>
+          <a:xfrm>
+            <a:off x="13830300" y="8642074"/>
+            <a:ext cx="2155526" cy="369332"/>
+          </a:xfrm>
+          <a:prstGeom prst="rect">
+            <a:avLst/>
+          </a:prstGeom>
+          <a:noFill/>
+        </p:spPr>
+        <p:txBody>
+          <a:bodyPr wrap="none" rtlCol="0">
+            <a:spAutoFit/>
+          </a:bodyPr>
+          <a:lstStyle/>
+          <a:p>
+            <a:r>
+              <a:rPr lang="en-US" dirty="0"/>
+              <a:t>Set output directory</a:t>
+            </a:r>
+            <a:endParaRPr lang="en-DK" dirty="0"/>
+          </a:p>
+        </p:txBody>
+      </p:sp>
+      <p:sp>
+        <p:nvSpPr>
+          <p:cNvPr id="17" name="TextBox 16">
+            <a:extLst>
+              <a:ext uri="{FF2B5EF4-FFF2-40B4-BE49-F238E27FC236}">
+                <a16:creationId xmlns:a16="http://schemas.microsoft.com/office/drawing/2014/main" id="{B980D129-C1B6-6C6A-47D8-EB5016C82A70}"/>
+              </a:ext>
+            </a:extLst>
+          </p:cNvPr>
+          <p:cNvSpPr txBox="1"/>
+          <p:nvPr/>
+        </p:nvSpPr>
+        <p:spPr>
+          <a:xfrm>
+            <a:off x="11175160" y="9676848"/>
+            <a:ext cx="3185680" cy="369332"/>
+          </a:xfrm>
+          <a:prstGeom prst="rect">
+            <a:avLst/>
+          </a:prstGeom>
+          <a:noFill/>
+        </p:spPr>
+        <p:txBody>
+          <a:bodyPr wrap="none" rtlCol="0">
+            <a:spAutoFit/>
+          </a:bodyPr>
+          <a:lstStyle/>
+          <a:p>
+            <a:r>
+              <a:rPr lang="en-US" dirty="0"/>
+              <a:t>Rerun all post-session actions</a:t>
+            </a:r>
+            <a:endParaRPr lang="en-DK" dirty="0"/>
+          </a:p>
+        </p:txBody>
+      </p:sp>
+    </p:spTree>
+    <p:extLst>
+      <p:ext uri="{BB962C8B-B14F-4D97-AF65-F5344CB8AC3E}">
+        <p14:creationId xmlns:p14="http://schemas.microsoft.com/office/powerpoint/2010/main" val="1724604041"/>
+      </p:ext>
+    </p:extLst>
+  </p:cSld>
+  <p:clrMapOvr>
+    <a:masterClrMapping/>
+  </p:clrMapOvr>
+</p:sld>
+</file>
+
+<file path=ppt/slides/slide4.xml><?xml version="1.0" encoding="utf-8"?>
+<p:sld xmlns:a="http://schemas.openxmlformats.org/drawingml/2006/main" xmlns:r="http://schemas.openxmlformats.org/officeDocument/2006/relationships" xmlns:p="http://schemas.openxmlformats.org/presentationml/2006/main">
+  <p:cSld>
+    <p:spTree>
+      <p:nvGrpSpPr>
+        <p:cNvPr id="1" name=""/>
+        <p:cNvGrpSpPr/>
+        <p:nvPr/>
+      </p:nvGrpSpPr>
+      <p:grpSpPr>
+        <a:xfrm>
+          <a:off x="0" y="0"/>
+          <a:ext cx="0" cy="0"/>
+          <a:chOff x="0" y="0"/>
+          <a:chExt cx="0" cy="0"/>
+        </a:xfrm>
+      </p:grpSpPr>
+      <p:pic>
+        <p:nvPicPr>
+          <p:cNvPr id="3" name="Picture 2" descr="The image shows a LabBench interface with tabs labeled Protocol, Setup, Data, and includes options to Create and Export.&#10;&#10;AI-generated content may be incorrect.">
+            <a:extLst>
+              <a:ext uri="{FF2B5EF4-FFF2-40B4-BE49-F238E27FC236}">
+                <a16:creationId xmlns:a16="http://schemas.microsoft.com/office/drawing/2014/main" id="{FBC0DBC4-8B0C-276E-900B-FE9465494DFA}"/>
+              </a:ext>
+            </a:extLst>
+          </p:cNvPr>
+          <p:cNvPicPr>
+            <a:picLocks noChangeAspect="1"/>
+          </p:cNvPicPr>
+          <p:nvPr/>
+        </p:nvPicPr>
+        <p:blipFill>
+          <a:blip r:embed="rId2"/>
+          <a:srcRect t="85193"/>
+          <a:stretch>
+            <a:fillRect/>
+          </a:stretch>
+        </p:blipFill>
+        <p:spPr>
+          <a:xfrm>
+            <a:off x="8100556" y="8128000"/>
+            <a:ext cx="5400000" cy="898081"/>
+          </a:xfrm>
+          <a:prstGeom prst="rect">
+            <a:avLst/>
+          </a:prstGeom>
+        </p:spPr>
+      </p:pic>
+      <p:pic>
+        <p:nvPicPr>
+          <p:cNvPr id="4" name="Picture 3" descr="The image shows a LabBench interface with tabs labeled Protocol, Setup, Data, and includes options to Create and Export.&#10;&#10;AI-generated content may be incorrect.">
+            <a:extLst>
+              <a:ext uri="{FF2B5EF4-FFF2-40B4-BE49-F238E27FC236}">
+                <a16:creationId xmlns:a16="http://schemas.microsoft.com/office/drawing/2014/main" id="{6AF11513-F0FC-3FEF-5ADC-A365124FB8AC}"/>
+              </a:ext>
+            </a:extLst>
+          </p:cNvPr>
+          <p:cNvPicPr>
+            <a:picLocks noChangeAspect="1"/>
+          </p:cNvPicPr>
+          <p:nvPr/>
+        </p:nvPicPr>
+        <p:blipFill>
+          <a:blip r:embed="rId2"/>
+          <a:srcRect b="52288"/>
+          <a:stretch>
+            <a:fillRect/>
+          </a:stretch>
+        </p:blipFill>
+        <p:spPr>
+          <a:xfrm>
+            <a:off x="8100556" y="5577065"/>
+            <a:ext cx="5400000" cy="2893836"/>
+          </a:xfrm>
+          <a:prstGeom prst="rect">
+            <a:avLst/>
+          </a:prstGeom>
+        </p:spPr>
+      </p:pic>
+      <p:sp>
+        <p:nvSpPr>
+          <p:cNvPr id="6" name="Rectangle: Rounded Corners 5">
+            <a:extLst>
+              <a:ext uri="{FF2B5EF4-FFF2-40B4-BE49-F238E27FC236}">
+                <a16:creationId xmlns:a16="http://schemas.microsoft.com/office/drawing/2014/main" id="{490556F4-DD56-8F56-7064-DFC6ED0985EE}"/>
+              </a:ext>
+            </a:extLst>
+          </p:cNvPr>
+          <p:cNvSpPr/>
+          <p:nvPr/>
+        </p:nvSpPr>
+        <p:spPr>
+          <a:xfrm>
+            <a:off x="11560174" y="8616950"/>
+            <a:ext cx="860426" cy="282575"/>
+          </a:xfrm>
+          <a:prstGeom prst="roundRect">
+            <a:avLst/>
+          </a:prstGeom>
+          <a:noFill/>
+          <a:ln>
+            <a:solidFill>
+              <a:srgbClr val="FF0000"/>
+            </a:solidFill>
+          </a:ln>
+        </p:spPr>
+        <p:style>
+          <a:lnRef idx="2">
+            <a:schemeClr val="accent1">
+              <a:shade val="15000"/>
+            </a:schemeClr>
+          </a:lnRef>
+          <a:fillRef idx="1">
+            <a:schemeClr val="accent1"/>
+          </a:fillRef>
+          <a:effectRef idx="0">
+            <a:schemeClr val="accent1"/>
+          </a:effectRef>
+          <a:fontRef idx="minor">
+            <a:schemeClr val="lt1"/>
+          </a:fontRef>
+        </p:style>
+        <p:txBody>
+          <a:bodyPr rtlCol="0" anchor="ctr"/>
+          <a:lstStyle/>
+          <a:p>
+            <a:pPr algn="ctr"/>
+            <a:endParaRPr lang="en-DK"/>
+          </a:p>
+        </p:txBody>
+      </p:sp>
+      <p:sp>
+        <p:nvSpPr>
+          <p:cNvPr id="7" name="Rectangle: Rounded Corners 6">
+            <a:extLst>
+              <a:ext uri="{FF2B5EF4-FFF2-40B4-BE49-F238E27FC236}">
+                <a16:creationId xmlns:a16="http://schemas.microsoft.com/office/drawing/2014/main" id="{DFB9C210-A407-7B85-B1D9-D9FE3518587E}"/>
+              </a:ext>
+            </a:extLst>
+          </p:cNvPr>
+          <p:cNvSpPr/>
+          <p:nvPr/>
+        </p:nvSpPr>
+        <p:spPr>
+          <a:xfrm>
+            <a:off x="12514490" y="8613553"/>
+            <a:ext cx="860426" cy="282575"/>
+          </a:xfrm>
+          <a:prstGeom prst="roundRect">
+            <a:avLst/>
+          </a:prstGeom>
+          <a:noFill/>
+          <a:ln>
+            <a:solidFill>
+              <a:srgbClr val="FF0000"/>
+            </a:solidFill>
+          </a:ln>
+        </p:spPr>
+        <p:style>
+          <a:lnRef idx="2">
+            <a:schemeClr val="accent1">
+              <a:shade val="15000"/>
+            </a:schemeClr>
+          </a:lnRef>
+          <a:fillRef idx="1">
+            <a:schemeClr val="accent1"/>
+          </a:fillRef>
+          <a:effectRef idx="0">
+            <a:schemeClr val="accent1"/>
+          </a:effectRef>
+          <a:fontRef idx="minor">
+            <a:schemeClr val="lt1"/>
+          </a:fontRef>
+        </p:style>
+        <p:txBody>
+          <a:bodyPr rtlCol="0" anchor="ctr"/>
+          <a:lstStyle/>
+          <a:p>
+            <a:pPr algn="ctr"/>
+            <a:endParaRPr lang="en-DK"/>
+          </a:p>
+        </p:txBody>
+      </p:sp>
+      <p:sp>
+        <p:nvSpPr>
+          <p:cNvPr id="8" name="Rectangle: Rounded Corners 7">
+            <a:extLst>
+              <a:ext uri="{FF2B5EF4-FFF2-40B4-BE49-F238E27FC236}">
+                <a16:creationId xmlns:a16="http://schemas.microsoft.com/office/drawing/2014/main" id="{B63B407D-9243-C763-8BB4-D46C48BA6D70}"/>
+              </a:ext>
+            </a:extLst>
+          </p:cNvPr>
+          <p:cNvSpPr/>
+          <p:nvPr/>
+        </p:nvSpPr>
+        <p:spPr>
+          <a:xfrm>
+            <a:off x="12968288" y="6293333"/>
+            <a:ext cx="342900" cy="221767"/>
+          </a:xfrm>
+          <a:prstGeom prst="roundRect">
+            <a:avLst/>
+          </a:prstGeom>
+          <a:noFill/>
+          <a:ln>
+            <a:solidFill>
+              <a:srgbClr val="FF0000"/>
+            </a:solidFill>
+          </a:ln>
+        </p:spPr>
+        <p:style>
+          <a:lnRef idx="2">
+            <a:schemeClr val="accent1">
+              <a:shade val="15000"/>
+            </a:schemeClr>
+          </a:lnRef>
+          <a:fillRef idx="1">
+            <a:schemeClr val="accent1"/>
+          </a:fillRef>
+          <a:effectRef idx="0">
+            <a:schemeClr val="accent1"/>
+          </a:effectRef>
+          <a:fontRef idx="minor">
+            <a:schemeClr val="lt1"/>
+          </a:fontRef>
+        </p:style>
+        <p:txBody>
+          <a:bodyPr rtlCol="0" anchor="ctr"/>
+          <a:lstStyle/>
+          <a:p>
+            <a:pPr algn="ctr"/>
+            <a:endParaRPr lang="en-DK"/>
+          </a:p>
+        </p:txBody>
+      </p:sp>
+      <p:sp>
+        <p:nvSpPr>
+          <p:cNvPr id="9" name="TextBox 8">
+            <a:extLst>
+              <a:ext uri="{FF2B5EF4-FFF2-40B4-BE49-F238E27FC236}">
+                <a16:creationId xmlns:a16="http://schemas.microsoft.com/office/drawing/2014/main" id="{4AC29960-A54F-C203-2693-8C09FF3955FF}"/>
+              </a:ext>
+            </a:extLst>
+          </p:cNvPr>
+          <p:cNvSpPr txBox="1"/>
+          <p:nvPr/>
+        </p:nvSpPr>
+        <p:spPr>
+          <a:xfrm>
+            <a:off x="13872210" y="6219550"/>
+            <a:ext cx="1980479" cy="369332"/>
+          </a:xfrm>
+          <a:prstGeom prst="rect">
+            <a:avLst/>
+          </a:prstGeom>
+          <a:noFill/>
+        </p:spPr>
+        <p:txBody>
+          <a:bodyPr wrap="none" rtlCol="0">
+            <a:spAutoFit/>
+          </a:bodyPr>
+          <a:lstStyle/>
+          <a:p>
+            <a:r>
+              <a:rPr lang="en-US" dirty="0"/>
+              <a:t>Delete participant</a:t>
+            </a:r>
+            <a:endParaRPr lang="en-DK" dirty="0"/>
+          </a:p>
+        </p:txBody>
+      </p:sp>
+      <p:sp>
+        <p:nvSpPr>
+          <p:cNvPr id="10" name="TextBox 9">
+            <a:extLst>
+              <a:ext uri="{FF2B5EF4-FFF2-40B4-BE49-F238E27FC236}">
+                <a16:creationId xmlns:a16="http://schemas.microsoft.com/office/drawing/2014/main" id="{2150436A-C656-54B2-9DB4-0F2A2FCBE614}"/>
+              </a:ext>
+            </a:extLst>
+          </p:cNvPr>
+          <p:cNvSpPr txBox="1"/>
+          <p:nvPr/>
+        </p:nvSpPr>
+        <p:spPr>
+          <a:xfrm>
+            <a:off x="13872210" y="8570174"/>
+            <a:ext cx="1319848" cy="369332"/>
+          </a:xfrm>
+          <a:prstGeom prst="rect">
+            <a:avLst/>
+          </a:prstGeom>
+          <a:noFill/>
+        </p:spPr>
+        <p:txBody>
+          <a:bodyPr wrap="none" rtlCol="0">
+            <a:spAutoFit/>
+          </a:bodyPr>
+          <a:lstStyle/>
+          <a:p>
+            <a:r>
+              <a:rPr lang="en-US" dirty="0"/>
+              <a:t>Export data</a:t>
+            </a:r>
+            <a:endParaRPr lang="en-DK" dirty="0"/>
+          </a:p>
+        </p:txBody>
+      </p:sp>
+      <p:sp>
+        <p:nvSpPr>
+          <p:cNvPr id="11" name="TextBox 10">
+            <a:extLst>
+              <a:ext uri="{FF2B5EF4-FFF2-40B4-BE49-F238E27FC236}">
+                <a16:creationId xmlns:a16="http://schemas.microsoft.com/office/drawing/2014/main" id="{A423BA7D-B987-BDE9-8A6F-80AB20F84096}"/>
+              </a:ext>
+            </a:extLst>
+          </p:cNvPr>
+          <p:cNvSpPr txBox="1"/>
+          <p:nvPr/>
+        </p:nvSpPr>
+        <p:spPr>
+          <a:xfrm>
+            <a:off x="10992325" y="9296400"/>
+            <a:ext cx="1996124" cy="369332"/>
+          </a:xfrm>
+          <a:prstGeom prst="rect">
+            <a:avLst/>
+          </a:prstGeom>
+          <a:noFill/>
+        </p:spPr>
+        <p:txBody>
+          <a:bodyPr wrap="none" rtlCol="0">
+            <a:spAutoFit/>
+          </a:bodyPr>
+          <a:lstStyle/>
+          <a:p>
+            <a:r>
+              <a:rPr lang="en-US" dirty="0"/>
+              <a:t>Create participant</a:t>
+            </a:r>
+            <a:endParaRPr lang="en-DK" dirty="0"/>
+          </a:p>
+        </p:txBody>
+      </p:sp>
+      <p:cxnSp>
+        <p:nvCxnSpPr>
+          <p:cNvPr id="13" name="Straight Arrow Connector 12">
+            <a:extLst>
+              <a:ext uri="{FF2B5EF4-FFF2-40B4-BE49-F238E27FC236}">
+                <a16:creationId xmlns:a16="http://schemas.microsoft.com/office/drawing/2014/main" id="{1B8EDB39-62F0-3B6D-7D92-413BA118299B}"/>
+              </a:ext>
+            </a:extLst>
+          </p:cNvPr>
+          <p:cNvCxnSpPr>
+            <a:stCxn id="9" idx="1"/>
+            <a:endCxn id="8" idx="3"/>
+          </p:cNvCxnSpPr>
+          <p:nvPr/>
+        </p:nvCxnSpPr>
+        <p:spPr>
+          <a:xfrm flipH="1">
+            <a:off x="13311188" y="6404216"/>
+            <a:ext cx="561022" cy="1"/>
+          </a:xfrm>
+          <a:prstGeom prst="straightConnector1">
+            <a:avLst/>
+          </a:prstGeom>
+          <a:ln w="28575">
+            <a:solidFill>
+              <a:srgbClr val="FF0000"/>
+            </a:solidFill>
+            <a:tailEnd type="triangle"/>
+          </a:ln>
+        </p:spPr>
+        <p:style>
+          <a:lnRef idx="2">
+            <a:schemeClr val="accent1"/>
+          </a:lnRef>
+          <a:fillRef idx="0">
+            <a:schemeClr val="accent1"/>
+          </a:fillRef>
+          <a:effectRef idx="1">
+            <a:schemeClr val="accent1"/>
+          </a:effectRef>
+          <a:fontRef idx="minor">
+            <a:schemeClr val="tx1"/>
+          </a:fontRef>
+        </p:style>
+      </p:cxnSp>
+      <p:cxnSp>
+        <p:nvCxnSpPr>
+          <p:cNvPr id="14" name="Straight Arrow Connector 13">
+            <a:extLst>
+              <a:ext uri="{FF2B5EF4-FFF2-40B4-BE49-F238E27FC236}">
+                <a16:creationId xmlns:a16="http://schemas.microsoft.com/office/drawing/2014/main" id="{13BF4133-4ECA-F7F0-C080-3B7C6336970F}"/>
+              </a:ext>
+            </a:extLst>
+          </p:cNvPr>
+          <p:cNvCxnSpPr>
+            <a:cxnSpLocks/>
+            <a:stCxn id="10" idx="1"/>
+            <a:endCxn id="7" idx="3"/>
+          </p:cNvCxnSpPr>
+          <p:nvPr/>
+        </p:nvCxnSpPr>
+        <p:spPr>
+          <a:xfrm flipH="1">
+            <a:off x="13374916" y="8754840"/>
+            <a:ext cx="497294" cy="1"/>
+          </a:xfrm>
+          <a:prstGeom prst="straightConnector1">
+            <a:avLst/>
+          </a:prstGeom>
+          <a:ln w="28575">
+            <a:solidFill>
+              <a:srgbClr val="FF0000"/>
+            </a:solidFill>
+            <a:tailEnd type="triangle"/>
+          </a:ln>
+        </p:spPr>
+        <p:style>
+          <a:lnRef idx="2">
+            <a:schemeClr val="accent1"/>
+          </a:lnRef>
+          <a:fillRef idx="0">
+            <a:schemeClr val="accent1"/>
+          </a:fillRef>
+          <a:effectRef idx="1">
+            <a:schemeClr val="accent1"/>
+          </a:effectRef>
+          <a:fontRef idx="minor">
+            <a:schemeClr val="tx1"/>
+          </a:fontRef>
+        </p:style>
+      </p:cxnSp>
+      <p:cxnSp>
+        <p:nvCxnSpPr>
+          <p:cNvPr id="15" name="Straight Arrow Connector 14">
+            <a:extLst>
+              <a:ext uri="{FF2B5EF4-FFF2-40B4-BE49-F238E27FC236}">
+                <a16:creationId xmlns:a16="http://schemas.microsoft.com/office/drawing/2014/main" id="{2598D38E-D9DC-10AB-E828-1C675EA5C5C9}"/>
+              </a:ext>
+            </a:extLst>
+          </p:cNvPr>
+          <p:cNvCxnSpPr>
+            <a:cxnSpLocks/>
+            <a:stCxn id="11" idx="0"/>
+          </p:cNvCxnSpPr>
+          <p:nvPr/>
+        </p:nvCxnSpPr>
+        <p:spPr>
+          <a:xfrm flipV="1">
+            <a:off x="11990387" y="8896128"/>
+            <a:ext cx="0" cy="400272"/>
+          </a:xfrm>
+          <a:prstGeom prst="straightConnector1">
+            <a:avLst/>
+          </a:prstGeom>
+          <a:ln w="28575">
+            <a:solidFill>
+              <a:srgbClr val="FF0000"/>
+            </a:solidFill>
+            <a:tailEnd type="triangle"/>
+          </a:ln>
+        </p:spPr>
+        <p:style>
+          <a:lnRef idx="2">
+            <a:schemeClr val="accent1"/>
+          </a:lnRef>
+          <a:fillRef idx="0">
+            <a:schemeClr val="accent1"/>
+          </a:fillRef>
+          <a:effectRef idx="1">
+            <a:schemeClr val="accent1"/>
+          </a:effectRef>
+          <a:fontRef idx="minor">
+            <a:schemeClr val="tx1"/>
+          </a:fontRef>
+        </p:style>
+      </p:cxnSp>
+    </p:spTree>
+    <p:extLst>
+      <p:ext uri="{BB962C8B-B14F-4D97-AF65-F5344CB8AC3E}">
+        <p14:creationId xmlns:p14="http://schemas.microsoft.com/office/powerpoint/2010/main" val="3022186570"/>
+      </p:ext>
+    </p:extLst>
+  </p:cSld>
+  <p:clrMapOvr>
+    <a:masterClrMapping/>
+  </p:clrMapOvr>
+</p:sld>
+</file>
+
+<file path=ppt/slides/slide5.xml><?xml version="1.0" encoding="utf-8"?>
+<p:sld xmlns:a="http://schemas.openxmlformats.org/drawingml/2006/main" xmlns:r="http://schemas.openxmlformats.org/officeDocument/2006/relationships" xmlns:p="http://schemas.openxmlformats.org/presentationml/2006/main">
+  <p:cSld>
+    <p:spTree>
+      <p:nvGrpSpPr>
+        <p:cNvPr id="1" name=""/>
+        <p:cNvGrpSpPr/>
+        <p:nvPr/>
+      </p:nvGrpSpPr>
+      <p:grpSpPr>
+        <a:xfrm>
+          <a:off x="0" y="0"/>
+          <a:ext cx="0" cy="0"/>
+          <a:chOff x="0" y="0"/>
+          <a:chExt cx="0" cy="0"/>
+        </a:xfrm>
+      </p:grpSpPr>
+      <p:pic>
+        <p:nvPicPr>
+          <p:cNvPr id="3" name="Picture 2" descr="Session ID&#10;&#10;AI-generated content may be incorrect.">
+            <a:extLst>
+              <a:ext uri="{FF2B5EF4-FFF2-40B4-BE49-F238E27FC236}">
+                <a16:creationId xmlns:a16="http://schemas.microsoft.com/office/drawing/2014/main" id="{E29318D1-A123-54C8-D842-2C011160E725}"/>
+              </a:ext>
+            </a:extLst>
+          </p:cNvPr>
+          <p:cNvPicPr>
+            <a:picLocks noChangeAspect="1"/>
+          </p:cNvPicPr>
+          <p:nvPr/>
+        </p:nvPicPr>
+        <p:blipFill>
+          <a:blip r:embed="rId2"/>
+          <a:stretch>
+            <a:fillRect/>
+          </a:stretch>
+        </p:blipFill>
+        <p:spPr>
+          <a:xfrm>
+            <a:off x="7075761" y="6299868"/>
+            <a:ext cx="7449590" cy="1800476"/>
+          </a:xfrm>
+          <a:prstGeom prst="rect">
+            <a:avLst/>
+          </a:prstGeom>
+        </p:spPr>
+      </p:pic>
+    </p:spTree>
+    <p:extLst>
+      <p:ext uri="{BB962C8B-B14F-4D97-AF65-F5344CB8AC3E}">
+        <p14:creationId xmlns:p14="http://schemas.microsoft.com/office/powerpoint/2010/main" val="842948556"/>
+      </p:ext>
+    </p:extLst>
+  </p:cSld>
+  <p:clrMapOvr>
+    <a:masterClrMapping/>
+  </p:clrMapOvr>
+</p:sld>
+</file>
+
+<file path=ppt/slides/slide6.xml><?xml version="1.0" encoding="utf-8"?>
+<p:sld xmlns:a="http://schemas.openxmlformats.org/drawingml/2006/main" xmlns:r="http://schemas.openxmlformats.org/officeDocument/2006/relationships" xmlns:p="http://schemas.openxmlformats.org/presentationml/2006/main">
+  <p:cSld>
+    <p:spTree>
+      <p:nvGrpSpPr>
+        <p:cNvPr id="1" name=""/>
+        <p:cNvGrpSpPr/>
+        <p:nvPr/>
+      </p:nvGrpSpPr>
+      <p:grpSpPr>
+        <a:xfrm>
+          <a:off x="0" y="0"/>
+          <a:ext cx="0" cy="0"/>
+          <a:chOff x="0" y="0"/>
+          <a:chExt cx="0" cy="0"/>
+        </a:xfrm>
+      </p:grpSpPr>
+      <p:pic>
+        <p:nvPicPr>
+          <p:cNvPr id="3" name="Picture 2" descr="The image shows a user interface with tabs labeled 'ID' and 'Investigator,' and options to 'Cancel' and 'Add,' with text content suggesting the removal of a character 'Ronch' from a document.&#10;&#10;AI-generated content may be incorrect.">
+            <a:extLst>
+              <a:ext uri="{FF2B5EF4-FFF2-40B4-BE49-F238E27FC236}">
+                <a16:creationId xmlns:a16="http://schemas.microsoft.com/office/drawing/2014/main" id="{0444A8A3-F1B8-F18B-4FD6-B9FEB8F89758}"/>
+              </a:ext>
+            </a:extLst>
+          </p:cNvPr>
+          <p:cNvPicPr>
+            <a:picLocks noChangeAspect="1"/>
+          </p:cNvPicPr>
+          <p:nvPr/>
+        </p:nvPicPr>
+        <p:blipFill>
+          <a:blip r:embed="rId2"/>
+          <a:srcRect t="1575" b="2627"/>
+          <a:stretch>
+            <a:fillRect/>
+          </a:stretch>
+        </p:blipFill>
+        <p:spPr>
+          <a:xfrm>
+            <a:off x="8519000" y="5394960"/>
+            <a:ext cx="4563112" cy="3093720"/>
+          </a:xfrm>
+          <a:prstGeom prst="rect">
+            <a:avLst/>
+          </a:prstGeom>
+        </p:spPr>
+      </p:pic>
+    </p:spTree>
+    <p:extLst>
+      <p:ext uri="{BB962C8B-B14F-4D97-AF65-F5344CB8AC3E}">
+        <p14:creationId xmlns:p14="http://schemas.microsoft.com/office/powerpoint/2010/main" val="2864224606"/>
+      </p:ext>
+    </p:extLst>
+  </p:cSld>
+  <p:clrMapOvr>
+    <a:masterClrMapping/>
+  </p:clrMapOvr>
+</p:sld>
+</file>
+
+<file path=ppt/slides/slide7.xml><?xml version="1.0" encoding="utf-8"?>
+<p:sld xmlns:a="http://schemas.openxmlformats.org/drawingml/2006/main" xmlns:r="http://schemas.openxmlformats.org/officeDocument/2006/relationships" xmlns:p="http://schemas.openxmlformats.org/presentationml/2006/main">
+  <p:cSld>
+    <p:spTree>
+      <p:nvGrpSpPr>
+        <p:cNvPr id="1" name=""/>
+        <p:cNvGrpSpPr/>
+        <p:nvPr/>
+      </p:nvGrpSpPr>
+      <p:grpSpPr>
+        <a:xfrm>
+          <a:off x="0" y="0"/>
+          <a:ext cx="0" cy="0"/>
+          <a:chOff x="0" y="0"/>
+          <a:chExt cx="0" cy="0"/>
+        </a:xfrm>
+      </p:grpSpPr>
+      <p:pic>
+        <p:nvPicPr>
+          <p:cNvPr id="3" name="Picture 2" descr="OK&#10;&#10;AI-generated content may be incorrect.">
+            <a:extLst>
+              <a:ext uri="{FF2B5EF4-FFF2-40B4-BE49-F238E27FC236}">
+                <a16:creationId xmlns:a16="http://schemas.microsoft.com/office/drawing/2014/main" id="{8CC79426-57DC-591A-D1A0-DE0FEC626D65}"/>
+              </a:ext>
+            </a:extLst>
+          </p:cNvPr>
+          <p:cNvPicPr>
+            <a:picLocks noChangeAspect="1"/>
+          </p:cNvPicPr>
+          <p:nvPr/>
+        </p:nvPicPr>
+        <p:blipFill>
+          <a:blip r:embed="rId2"/>
+          <a:srcRect t="2470"/>
+          <a:stretch>
+            <a:fillRect/>
+          </a:stretch>
+        </p:blipFill>
+        <p:spPr>
+          <a:xfrm>
+            <a:off x="8990554" y="5438775"/>
+            <a:ext cx="3620005" cy="3614202"/>
+          </a:xfrm>
+          <a:prstGeom prst="rect">
+            <a:avLst/>
+          </a:prstGeom>
+        </p:spPr>
+      </p:pic>
+    </p:spTree>
+    <p:extLst>
+      <p:ext uri="{BB962C8B-B14F-4D97-AF65-F5344CB8AC3E}">
+        <p14:creationId xmlns:p14="http://schemas.microsoft.com/office/powerpoint/2010/main" val="3689345836"/>
+      </p:ext>
+    </p:extLst>
+  </p:cSld>
+  <p:clrMapOvr>
+    <a:masterClrMapping/>
+  </p:clrMapOvr>
+</p:sld>
+</file>
+
+<file path=ppt/slides/slide8.xml><?xml version="1.0" encoding="utf-8"?>
+<p:sld xmlns:a="http://schemas.openxmlformats.org/drawingml/2006/main" xmlns:r="http://schemas.openxmlformats.org/officeDocument/2006/relationships" xmlns:p="http://schemas.openxmlformats.org/presentationml/2006/main">
+  <p:cSld>
+    <p:spTree>
+      <p:nvGrpSpPr>
+        <p:cNvPr id="1" name=""/>
+        <p:cNvGrpSpPr/>
+        <p:nvPr/>
+      </p:nvGrpSpPr>
+      <p:grpSpPr>
+        <a:xfrm>
+          <a:off x="0" y="0"/>
+          <a:ext cx="0" cy="0"/>
+          <a:chOff x="0" y="0"/>
+          <a:chExt cx="0" cy="0"/>
+        </a:xfrm>
+      </p:grpSpPr>
+      <p:pic>
+        <p:nvPicPr>
+          <p:cNvPr id="3" name="Picture 2" descr="The image displays a LabBench I/O interface screen with a positive logic system, showing a low byte of 5.0V and a high byte that is unconnected.&#10;&#10;AI-generated content may be incorrect.">
+            <a:extLst>
+              <a:ext uri="{FF2B5EF4-FFF2-40B4-BE49-F238E27FC236}">
+                <a16:creationId xmlns:a16="http://schemas.microsoft.com/office/drawing/2014/main" id="{E7C841BB-39CA-A0E2-5374-91D3A59EEF72}"/>
+              </a:ext>
+            </a:extLst>
+          </p:cNvPr>
+          <p:cNvPicPr>
+            <a:picLocks noChangeAspect="1"/>
+          </p:cNvPicPr>
+          <p:nvPr/>
+        </p:nvPicPr>
+        <p:blipFill>
+          <a:blip r:embed="rId2"/>
+          <a:srcRect b="3968"/>
+          <a:stretch>
+            <a:fillRect/>
+          </a:stretch>
+        </p:blipFill>
+        <p:spPr>
+          <a:xfrm>
+            <a:off x="9195370" y="5847367"/>
+            <a:ext cx="3210373" cy="2598133"/>
+          </a:xfrm>
+          <a:prstGeom prst="rect">
+            <a:avLst/>
+          </a:prstGeom>
+        </p:spPr>
+      </p:pic>
+    </p:spTree>
+    <p:extLst>
+      <p:ext uri="{BB962C8B-B14F-4D97-AF65-F5344CB8AC3E}">
+        <p14:creationId xmlns:p14="http://schemas.microsoft.com/office/powerpoint/2010/main" val="1645677563"/>
+      </p:ext>
+    </p:extLst>
+  </p:cSld>
+  <p:clrMapOvr>
+    <a:masterClrMapping/>
+  </p:clrMapOvr>
+</p:sld>
+</file>
+
+<file path=ppt/slides/slide9.xml><?xml version="1.0" encoding="utf-8"?>
+<p:sld xmlns:a="http://schemas.openxmlformats.org/drawingml/2006/main" xmlns:r="http://schemas.openxmlformats.org/officeDocument/2006/relationships" xmlns:p="http://schemas.openxmlformats.org/presentationml/2006/main">
+  <p:cSld>
+    <p:spTree>
+      <p:nvGrpSpPr>
+        <p:cNvPr id="1" name=""/>
+        <p:cNvGrpSpPr/>
+        <p:nvPr/>
+      </p:nvGrpSpPr>
+      <p:grpSpPr>
+        <a:xfrm>
+          <a:off x="0" y="0"/>
+          <a:ext cx="0" cy="0"/>
+          <a:chOff x="0" y="0"/>
+          <a:chExt cx="0" cy="0"/>
+        </a:xfrm>
+      </p:grpSpPr>
+      <p:pic>
+        <p:nvPicPr>
+          <p:cNvPr id="3" name="Picture 2" descr="The image shows a joystick interface with various buttons, a questionnaire section, a label input field, and numeric buttons for navigation.&#10;&#10;AI-generated content may be incorrect.">
+            <a:extLst>
+              <a:ext uri="{FF2B5EF4-FFF2-40B4-BE49-F238E27FC236}">
+                <a16:creationId xmlns:a16="http://schemas.microsoft.com/office/drawing/2014/main" id="{C6A7807E-6AE4-8B8E-32E1-785E9F6917B1}"/>
+              </a:ext>
+            </a:extLst>
+          </p:cNvPr>
+          <p:cNvPicPr>
+            <a:picLocks noChangeAspect="1"/>
+          </p:cNvPicPr>
+          <p:nvPr/>
+        </p:nvPicPr>
+        <p:blipFill>
+          <a:blip r:embed="rId2"/>
+          <a:srcRect t="1495"/>
+          <a:stretch>
+            <a:fillRect/>
+          </a:stretch>
+        </p:blipFill>
+        <p:spPr>
+          <a:xfrm>
+            <a:off x="8752395" y="4483099"/>
+            <a:ext cx="4096322" cy="5517747"/>
+          </a:xfrm>
+          <a:prstGeom prst="rect">
+            <a:avLst/>
+          </a:prstGeom>
+        </p:spPr>
+      </p:pic>
+    </p:spTree>
+    <p:extLst>
+      <p:ext uri="{BB962C8B-B14F-4D97-AF65-F5344CB8AC3E}">
+        <p14:creationId xmlns:p14="http://schemas.microsoft.com/office/powerpoint/2010/main" val="982658955"/>
       </p:ext>
     </p:extLst>
   </p:cSld>
@@ -4382,6 +6501,26 @@
 </file>
 
 <file path=customXml/item1.xml><?xml version="1.0" encoding="utf-8"?>
+<?mso-contentType ?>
+<FormTemplates xmlns="http://schemas.microsoft.com/sharepoint/v3/contenttype/forms">
+  <Display>DocumentLibraryForm</Display>
+  <Edit>DocumentLibraryForm</Edit>
+  <New>DocumentLibraryForm</New>
+</FormTemplates>
+</file>
+
+<file path=customXml/item2.xml><?xml version="1.0" encoding="utf-8"?>
+<p:properties xmlns:p="http://schemas.microsoft.com/office/2006/metadata/properties" xmlns:xsi="http://www.w3.org/2001/XMLSchema-instance" xmlns:pc="http://schemas.microsoft.com/office/infopath/2007/PartnerControls">
+  <documentManagement>
+    <TaxCatchAll xmlns="6dfb7b4b-871d-4c24-9d42-16b14ecd044c" xsi:nil="true"/>
+    <lcf76f155ced4ddcb4097134ff3c332f xmlns="51c7d8ad-74c8-4833-8478-0d0a5cafce0c">
+      <Terms xmlns="http://schemas.microsoft.com/office/infopath/2007/PartnerControls"/>
+    </lcf76f155ced4ddcb4097134ff3c332f>
+  </documentManagement>
+</p:properties>
+</file>
+
+<file path=customXml/item3.xml><?xml version="1.0" encoding="utf-8"?>
 <ct:contentTypeSchema xmlns:ct="http://schemas.microsoft.com/office/2006/metadata/contentType" xmlns:ma="http://schemas.microsoft.com/office/2006/metadata/properties/metaAttributes" ct:_="" ma:_="" ma:contentTypeName="Document" ma:contentTypeID="0x0101005B996248A2D0E04D87B9DBB54D269DA4" ma:contentTypeVersion="18" ma:contentTypeDescription="Create a new document." ma:contentTypeScope="" ma:versionID="f22bde94a6705f7f7e236c14bc19f189">
   <xsd:schema xmlns:xsd="http://www.w3.org/2001/XMLSchema" xmlns:xs="http://www.w3.org/2001/XMLSchema" xmlns:p="http://schemas.microsoft.com/office/2006/metadata/properties" xmlns:ns2="51c7d8ad-74c8-4833-8478-0d0a5cafce0c" xmlns:ns3="6dfb7b4b-871d-4c24-9d42-16b14ecd044c" targetNamespace="http://schemas.microsoft.com/office/2006/metadata/properties" ma:root="true" ma:fieldsID="273248db29f554cba2c15e8dd349c138" ns2:_="" ns3:_="">
     <xsd:import namespace="51c7d8ad-74c8-4833-8478-0d0a5cafce0c"/>
@@ -4636,27 +6775,26 @@
 </ct:contentTypeSchema>
 </file>
 
-<file path=customXml/item2.xml><?xml version="1.0" encoding="utf-8"?>
-<p:properties xmlns:p="http://schemas.microsoft.com/office/2006/metadata/properties" xmlns:xsi="http://www.w3.org/2001/XMLSchema-instance" xmlns:pc="http://schemas.microsoft.com/office/infopath/2007/PartnerControls">
-  <documentManagement>
-    <TaxCatchAll xmlns="6dfb7b4b-871d-4c24-9d42-16b14ecd044c" xsi:nil="true"/>
-    <lcf76f155ced4ddcb4097134ff3c332f xmlns="51c7d8ad-74c8-4833-8478-0d0a5cafce0c">
-      <Terms xmlns="http://schemas.microsoft.com/office/infopath/2007/PartnerControls"/>
-    </lcf76f155ced4ddcb4097134ff3c332f>
-  </documentManagement>
-</p:properties>
+<file path=customXml/itemProps1.xml><?xml version="1.0" encoding="utf-8"?>
+<ds:datastoreItem xmlns:ds="http://schemas.openxmlformats.org/officeDocument/2006/customXml" ds:itemID="{EF875D47-8106-485E-98E0-D60C6A98DA6A}">
+  <ds:schemaRefs>
+    <ds:schemaRef ds:uri="http://schemas.microsoft.com/sharepoint/v3/contenttype/forms"/>
+  </ds:schemaRefs>
+</ds:datastoreItem>
 </file>
 
-<file path=customXml/item3.xml><?xml version="1.0" encoding="utf-8"?>
-<?mso-contentType ?>
-<FormTemplates xmlns="http://schemas.microsoft.com/sharepoint/v3/contenttype/forms">
-  <Display>DocumentLibraryForm</Display>
-  <Edit>DocumentLibraryForm</Edit>
-  <New>DocumentLibraryForm</New>
-</FormTemplates>
+<file path=customXml/itemProps2.xml><?xml version="1.0" encoding="utf-8"?>
+<ds:datastoreItem xmlns:ds="http://schemas.openxmlformats.org/officeDocument/2006/customXml" ds:itemID="{2EF670CE-B0AA-4D52-AFC6-AA4BF7D46EEA}">
+  <ds:schemaRefs>
+    <ds:schemaRef ds:uri="http://schemas.microsoft.com/office/2006/metadata/properties"/>
+    <ds:schemaRef ds:uri="http://schemas.microsoft.com/office/infopath/2007/PartnerControls"/>
+    <ds:schemaRef ds:uri="6dfb7b4b-871d-4c24-9d42-16b14ecd044c"/>
+    <ds:schemaRef ds:uri="51c7d8ad-74c8-4833-8478-0d0a5cafce0c"/>
+  </ds:schemaRefs>
+</ds:datastoreItem>
 </file>
 
-<file path=customXml/itemProps1.xml><?xml version="1.0" encoding="utf-8"?>
+<file path=customXml/itemProps3.xml><?xml version="1.0" encoding="utf-8"?>
 <ds:datastoreItem xmlns:ds="http://schemas.openxmlformats.org/officeDocument/2006/customXml" ds:itemID="{172A1115-3E72-42E2-A544-7EAA53D3702E}">
   <ds:schemaRefs>
     <ds:schemaRef ds:uri="http://schemas.microsoft.com/office/2006/metadata/contentType"/>
@@ -4673,23 +6811,4 @@
     <ds:schemaRef ds:uri="http://schemas.microsoft.com/internal/obd"/>
   </ds:schemaRefs>
 </ds:datastoreItem>
-</file>
-
-<file path=customXml/itemProps2.xml><?xml version="1.0" encoding="utf-8"?>
-<ds:datastoreItem xmlns:ds="http://schemas.openxmlformats.org/officeDocument/2006/customXml" ds:itemID="{2EF670CE-B0AA-4D52-AFC6-AA4BF7D46EEA}">
-  <ds:schemaRefs>
-    <ds:schemaRef ds:uri="http://schemas.microsoft.com/office/2006/metadata/properties"/>
-    <ds:schemaRef ds:uri="http://schemas.microsoft.com/office/infopath/2007/PartnerControls"/>
-    <ds:schemaRef ds:uri="6dfb7b4b-871d-4c24-9d42-16b14ecd044c"/>
-    <ds:schemaRef ds:uri="51c7d8ad-74c8-4833-8478-0d0a5cafce0c"/>
-  </ds:schemaRefs>
-</ds:datastoreItem>
-</file>
-
-<file path=customXml/itemProps3.xml><?xml version="1.0" encoding="utf-8"?>
-<ds:datastoreItem xmlns:ds="http://schemas.openxmlformats.org/officeDocument/2006/customXml" ds:itemID="{EF875D47-8106-485E-98E0-D60C6A98DA6A}">
-  <ds:schemaRefs>
-    <ds:schemaRef ds:uri="http://schemas.microsoft.com/sharepoint/v3/contenttype/forms"/>
-  </ds:schemaRefs>
-</ds:datastoreItem>
 </file>
</xml_diff>